<commit_message>
Reconcile internship submission with full research history and critical review
</commit_message>
<xml_diff>
--- a/rapor/final_2026/deliverables/CS395_Digest_EfeHan_Keles_25September2026.pptx
+++ b/rapor/final_2026/deliverables/CS395_Digest_EfeHan_Keles_25September2026.pptx
@@ -2,13 +2,13 @@
 <file path=ppt/presentation.xml><?xml version="1.0" encoding="utf-8"?>
 <p:presentation xmlns:p="http://schemas.openxmlformats.org/presentationml/2006/main">
   <p:sldMasterIdLst>
-    <p:sldMasterId xmlns:r="http://schemas.openxmlformats.org/officeDocument/2006/relationships" id="2147483648" r:id="Ra45f460cb2e9424a"/>
+    <p:sldMasterId xmlns:r="http://schemas.openxmlformats.org/officeDocument/2006/relationships" id="2147483648" r:id="R7e23caebb0bd4da6"/>
   </p:sldMasterIdLst>
   <p:notesMasterIdLst>
-    <p:notesMasterId xmlns:r="http://schemas.openxmlformats.org/officeDocument/2006/relationships" r:id="Rf4cadce86bcf4f8f"/>
+    <p:notesMasterId xmlns:r="http://schemas.openxmlformats.org/officeDocument/2006/relationships" r:id="Ra875e68ac5154ffe"/>
   </p:notesMasterIdLst>
   <p:sldIdLst>
-    <p:sldId xmlns:r="http://schemas.openxmlformats.org/officeDocument/2006/relationships" id="256" r:id="Rabe4ed7808d84757"/>
+    <p:sldId xmlns:r="http://schemas.openxmlformats.org/officeDocument/2006/relationships" id="256" r:id="R4872d6e70b1540f0"/>
   </p:sldIdLst>
   <p:sldSz cx="12192000" cy="6858000"/>
   <p:notesSz cx="6858000" cy="9144000"/>
@@ -510,7 +510,7 @@
   </p:cSld>
   <p:clrMap bg1="lt1" tx1="dk1" bg2="lt2" tx2="dk2" accent1="accent1" accent2="accent2" accent3="accent3" accent4="accent4" accent5="accent5" accent6="accent6" hlink="hlink" folHlink="folHlink"/>
   <p:sldLayoutIdLst>
-    <p:sldLayoutId xmlns:r="http://schemas.openxmlformats.org/officeDocument/2006/relationships" id="2147483649" r:id="R86b2a5c3ede44661"/>
+    <p:sldLayoutId xmlns:r="http://schemas.openxmlformats.org/officeDocument/2006/relationships" id="2147483649" r:id="R0610ab7fe5874167"/>
   </p:sldLayoutIdLst>
   <p:txStyles>
     <p:titleStyle>
@@ -1061,7 +1061,7 @@
           <p:cNvPr id="12" name="">
             <a:extLst xmlns:a="http://schemas.openxmlformats.org/drawingml/2006/main">
               <a:ext uri="{FF2B5EF4-FFF2-40B4-BE49-F238E27FC236}">
-                <a16:creationId xmlns:a16="http://schemas.microsoft.com/office/drawing/2014/main" id="{C9A8DAAC-8270-4E95-826D-4A733D166E12}"/>
+                <a16:creationId xmlns:a16="http://schemas.microsoft.com/office/drawing/2014/main" id="{337A220E-E14F-4546-83BA-C4831A3BDF9D}"/>
               </a:ext>
             </a:extLst>
           </p:cNvPr>
@@ -1118,7 +1118,7 @@
           <p:cNvPr id="2" name="">
             <a:extLst xmlns:a="http://schemas.openxmlformats.org/drawingml/2006/main">
               <a:ext uri="{FF2B5EF4-FFF2-40B4-BE49-F238E27FC236}">
-                <a16:creationId xmlns:a16="http://schemas.microsoft.com/office/drawing/2014/main" id="{E2F059C6-AD6D-4709-8219-A9C21DABB47F}"/>
+                <a16:creationId xmlns:a16="http://schemas.microsoft.com/office/drawing/2014/main" id="{A91E0963-1095-4241-9CCD-688B7C0F713B}"/>
               </a:ext>
             </a:extLst>
           </p:cNvPr>
@@ -1175,7 +1175,7 @@
           <p:cNvPr id="3" name="">
             <a:extLst xmlns:a="http://schemas.openxmlformats.org/drawingml/2006/main">
               <a:ext uri="{FF2B5EF4-FFF2-40B4-BE49-F238E27FC236}">
-                <a16:creationId xmlns:a16="http://schemas.microsoft.com/office/drawing/2014/main" id="{58261A81-EA3D-4B39-9DB3-D32AAE2B3FB7}"/>
+                <a16:creationId xmlns:a16="http://schemas.microsoft.com/office/drawing/2014/main" id="{FA91C93A-42A6-467D-8CC3-64ACE72FA02C}"/>
               </a:ext>
             </a:extLst>
           </p:cNvPr>
@@ -1232,7 +1232,7 @@
           <p:cNvPr id="4" name="">
             <a:extLst xmlns:a="http://schemas.openxmlformats.org/drawingml/2006/main">
               <a:ext uri="{FF2B5EF4-FFF2-40B4-BE49-F238E27FC236}">
-                <a16:creationId xmlns:a16="http://schemas.microsoft.com/office/drawing/2014/main" id="{1363D21A-734B-4B10-AD57-0FA0B7B0093A}"/>
+                <a16:creationId xmlns:a16="http://schemas.microsoft.com/office/drawing/2014/main" id="{16B9E433-7047-431D-AD97-BFC4BCBC6422}"/>
               </a:ext>
             </a:extLst>
           </p:cNvPr>
@@ -1289,7 +1289,7 @@
           <p:cNvPr id="5" name="">
             <a:extLst xmlns:a="http://schemas.openxmlformats.org/drawingml/2006/main">
               <a:ext uri="{FF2B5EF4-FFF2-40B4-BE49-F238E27FC236}">
-                <a16:creationId xmlns:a16="http://schemas.microsoft.com/office/drawing/2014/main" id="{154D73CA-42DB-4AAD-BB45-0E7732FA5950}"/>
+                <a16:creationId xmlns:a16="http://schemas.microsoft.com/office/drawing/2014/main" id="{17A463B9-1147-41B0-82BE-091ACEBCB8F1}"/>
               </a:ext>
             </a:extLst>
           </p:cNvPr>
@@ -1369,7 +1369,7 @@
           <p:cNvPr id="6" name="">
             <a:extLst xmlns:a="http://schemas.openxmlformats.org/drawingml/2006/main">
               <a:ext uri="{FF2B5EF4-FFF2-40B4-BE49-F238E27FC236}">
-                <a16:creationId xmlns:a16="http://schemas.microsoft.com/office/drawing/2014/main" id="{A1D1E9B0-AEE7-48A0-AA33-2D0029C75750}"/>
+                <a16:creationId xmlns:a16="http://schemas.microsoft.com/office/drawing/2014/main" id="{511DE273-4287-424B-9039-B485BD207A45}"/>
               </a:ext>
             </a:extLst>
           </p:cNvPr>
@@ -1426,7 +1426,7 @@
           <p:cNvPr id="7" name="">
             <a:extLst xmlns:a="http://schemas.openxmlformats.org/drawingml/2006/main">
               <a:ext uri="{FF2B5EF4-FFF2-40B4-BE49-F238E27FC236}">
-                <a16:creationId xmlns:a16="http://schemas.microsoft.com/office/drawing/2014/main" id="{CE871CA0-FD57-4CD8-8277-BC7586692235}"/>
+                <a16:creationId xmlns:a16="http://schemas.microsoft.com/office/drawing/2014/main" id="{1B32F0FE-F2C0-446C-8E11-FB0C9C5CADD1}"/>
               </a:ext>
             </a:extLst>
           </p:cNvPr>
@@ -1506,7 +1506,7 @@
           <p:cNvPr id="8" name="">
             <a:extLst xmlns:a="http://schemas.openxmlformats.org/drawingml/2006/main">
               <a:ext uri="{FF2B5EF4-FFF2-40B4-BE49-F238E27FC236}">
-                <a16:creationId xmlns:a16="http://schemas.microsoft.com/office/drawing/2014/main" id="{7E9B3586-806D-4BD5-B589-F56103CC04C2}"/>
+                <a16:creationId xmlns:a16="http://schemas.microsoft.com/office/drawing/2014/main" id="{93650D1C-698F-495D-8065-E96325067601}"/>
               </a:ext>
             </a:extLst>
           </p:cNvPr>
@@ -1563,7 +1563,7 @@
           <p:cNvPr id="9" name="">
             <a:extLst xmlns:a="http://schemas.openxmlformats.org/drawingml/2006/main">
               <a:ext uri="{FF2B5EF4-FFF2-40B4-BE49-F238E27FC236}">
-                <a16:creationId xmlns:a16="http://schemas.microsoft.com/office/drawing/2014/main" id="{3B28677D-DB64-43F8-B114-48067B0798C8}"/>
+                <a16:creationId xmlns:a16="http://schemas.microsoft.com/office/drawing/2014/main" id="{014F7479-612A-4385-A5D5-BF6B0137F440}"/>
               </a:ext>
             </a:extLst>
           </p:cNvPr>
@@ -1643,7 +1643,7 @@
           <p:cNvPr id="10" name="">
             <a:extLst xmlns:a="http://schemas.openxmlformats.org/drawingml/2006/main">
               <a:ext uri="{FF2B5EF4-FFF2-40B4-BE49-F238E27FC236}">
-                <a16:creationId xmlns:a16="http://schemas.microsoft.com/office/drawing/2014/main" id="{0760C359-19C6-467A-BC6E-ABE1E8FE2084}"/>
+                <a16:creationId xmlns:a16="http://schemas.microsoft.com/office/drawing/2014/main" id="{57BA3E68-7F95-4997-ABF0-B28632E60BC3}"/>
               </a:ext>
             </a:extLst>
           </p:cNvPr>
@@ -1700,7 +1700,7 @@
           <p:cNvPr id="11" name="">
             <a:extLst xmlns:a="http://schemas.openxmlformats.org/drawingml/2006/main">
               <a:ext uri="{FF2B5EF4-FFF2-40B4-BE49-F238E27FC236}">
-                <a16:creationId xmlns:a16="http://schemas.microsoft.com/office/drawing/2014/main" id="{F012DFDB-5D16-40E0-AD79-2E973FF44C83}"/>
+                <a16:creationId xmlns:a16="http://schemas.microsoft.com/office/drawing/2014/main" id="{7C2870BB-AD03-4BB2-B033-BCCD075F6233}"/>
               </a:ext>
             </a:extLst>
           </p:cNvPr>
@@ -1778,7 +1778,7 @@
     </p:spTree>
     <p:extLst>
       <p:ext uri="{BB962C8B-B14F-4D97-AF65-F5344CB8AC3E}">
-        <p14:creationId xmlns:p14="http://schemas.microsoft.com/office/powerpoint/2010/main" val="1447473447"/>
+        <p14:creationId xmlns:p14="http://schemas.microsoft.com/office/powerpoint/2010/main" val="1823659372"/>
       </p:ext>
     </p:extLst>
   </p:cSld>

</xml_diff>

<commit_message>
docs: incorporate student internship details and refresh submission files
</commit_message>
<xml_diff>
--- a/rapor/final_2026/deliverables/CS395_Digest_EfeHan_Keles_25September2026.pptx
+++ b/rapor/final_2026/deliverables/CS395_Digest_EfeHan_Keles_25September2026.pptx
@@ -2,13 +2,13 @@
 <file path=ppt/presentation.xml><?xml version="1.0" encoding="utf-8"?>
 <p:presentation xmlns:p="http://schemas.openxmlformats.org/presentationml/2006/main">
   <p:sldMasterIdLst>
-    <p:sldMasterId xmlns:r="http://schemas.openxmlformats.org/officeDocument/2006/relationships" id="2147483648" r:id="R7e23caebb0bd4da6"/>
+    <p:sldMasterId xmlns:r="http://schemas.openxmlformats.org/officeDocument/2006/relationships" id="2147483648" r:id="R941de56f910e498d"/>
   </p:sldMasterIdLst>
   <p:notesMasterIdLst>
-    <p:notesMasterId xmlns:r="http://schemas.openxmlformats.org/officeDocument/2006/relationships" r:id="Ra875e68ac5154ffe"/>
+    <p:notesMasterId xmlns:r="http://schemas.openxmlformats.org/officeDocument/2006/relationships" r:id="R788d1c8eb40146e0"/>
   </p:notesMasterIdLst>
   <p:sldIdLst>
-    <p:sldId xmlns:r="http://schemas.openxmlformats.org/officeDocument/2006/relationships" id="256" r:id="R4872d6e70b1540f0"/>
+    <p:sldId xmlns:r="http://schemas.openxmlformats.org/officeDocument/2006/relationships" id="256" r:id="Rcb1e86cd8d4c451d"/>
   </p:sldIdLst>
   <p:sldSz cx="12192000" cy="6858000"/>
   <p:notesSz cx="6858000" cy="9144000"/>
@@ -442,7 +442,7 @@
           <a:lstStyle xmlns:a="http://schemas.openxmlformats.org/drawingml/2006/main"/>
           <a:p xmlns:a="http://schemas.openxmlformats.org/drawingml/2006/main">
             <a:r>
-              <a:t>Standalone internship digest. Original and social-style views use the same 320 development parents: 160 real and 160 AI. Social-style means long-side cap 1080 followed by JPEG75. E92 newly missed one original AI image caught by E43, so full acceptance failed despite the numeric milestone. Model2 remains experimental. The actual internship office/address is intentionally deferred by the student. Supervisor: Önder Çelebi. Full sources and limitations are in the report.</a:t>
+              <a:t>Standalone internship digest. Original and social-style views use the same 320 development parents: 160 real and 160 AI. Social-style means long-side cap 1080 followed by JPEG75. E92 newly missed one original AI image caught by E43, so full acceptance failed despite the numeric milestone. Model2 remains experimental. The student confirmed the internship office as Fatih Sultan Mehmet Mah., Balkan Cad. No:49, 34771 Ümraniye / İstanbul on 25 September 2026. Supervisor: Önder Çelebi. Full sources and limitations are in the report.</a:t>
             </a:r>
           </a:p>
         </p:txBody>
@@ -510,7 +510,7 @@
   </p:cSld>
   <p:clrMap bg1="lt1" tx1="dk1" bg2="lt2" tx2="dk2" accent1="accent1" accent2="accent2" accent3="accent3" accent4="accent4" accent5="accent5" accent6="accent6" hlink="hlink" folHlink="folHlink"/>
   <p:sldLayoutIdLst>
-    <p:sldLayoutId xmlns:r="http://schemas.openxmlformats.org/officeDocument/2006/relationships" id="2147483649" r:id="R0610ab7fe5874167"/>
+    <p:sldLayoutId xmlns:r="http://schemas.openxmlformats.org/officeDocument/2006/relationships" id="2147483649" r:id="Rd80baf28b3414adc"/>
   </p:sldLayoutIdLst>
   <p:txStyles>
     <p:titleStyle>
@@ -1058,10 +1058,10 @@
       </p:grpSpPr>
       <p:sp>
         <p:nvSpPr>
-          <p:cNvPr id="12" name="">
+          <p:cNvPr id="13" name="">
             <a:extLst xmlns:a="http://schemas.openxmlformats.org/drawingml/2006/main">
               <a:ext uri="{FF2B5EF4-FFF2-40B4-BE49-F238E27FC236}">
-                <a16:creationId xmlns:a16="http://schemas.microsoft.com/office/drawing/2014/main" id="{337A220E-E14F-4546-83BA-C4831A3BDF9D}"/>
+                <a16:creationId xmlns:a16="http://schemas.microsoft.com/office/drawing/2014/main" id="{B260F7F2-5393-4EB8-BDA9-2CABABEC85ED}"/>
               </a:ext>
             </a:extLst>
           </p:cNvPr>
@@ -1118,7 +1118,7 @@
           <p:cNvPr id="2" name="">
             <a:extLst xmlns:a="http://schemas.openxmlformats.org/drawingml/2006/main">
               <a:ext uri="{FF2B5EF4-FFF2-40B4-BE49-F238E27FC236}">
-                <a16:creationId xmlns:a16="http://schemas.microsoft.com/office/drawing/2014/main" id="{A91E0963-1095-4241-9CCD-688B7C0F713B}"/>
+                <a16:creationId xmlns:a16="http://schemas.microsoft.com/office/drawing/2014/main" id="{6227D0FB-EC32-4212-9A02-EF6206EE4E80}"/>
               </a:ext>
             </a:extLst>
           </p:cNvPr>
@@ -1175,7 +1175,7 @@
           <p:cNvPr id="3" name="">
             <a:extLst xmlns:a="http://schemas.openxmlformats.org/drawingml/2006/main">
               <a:ext uri="{FF2B5EF4-FFF2-40B4-BE49-F238E27FC236}">
-                <a16:creationId xmlns:a16="http://schemas.microsoft.com/office/drawing/2014/main" id="{FA91C93A-42A6-467D-8CC3-64ACE72FA02C}"/>
+                <a16:creationId xmlns:a16="http://schemas.microsoft.com/office/drawing/2014/main" id="{DCDEEB1D-E1EC-4E8D-B33D-21310322FAF8}"/>
               </a:ext>
             </a:extLst>
           </p:cNvPr>
@@ -1232,7 +1232,7 @@
           <p:cNvPr id="4" name="">
             <a:extLst xmlns:a="http://schemas.openxmlformats.org/drawingml/2006/main">
               <a:ext uri="{FF2B5EF4-FFF2-40B4-BE49-F238E27FC236}">
-                <a16:creationId xmlns:a16="http://schemas.microsoft.com/office/drawing/2014/main" id="{16B9E433-7047-431D-AD97-BFC4BCBC6422}"/>
+                <a16:creationId xmlns:a16="http://schemas.microsoft.com/office/drawing/2014/main" id="{1EA3C49A-2AF9-449A-B7BB-A32692F6DF8B}"/>
               </a:ext>
             </a:extLst>
           </p:cNvPr>
@@ -1289,7 +1289,7 @@
           <p:cNvPr id="5" name="">
             <a:extLst xmlns:a="http://schemas.openxmlformats.org/drawingml/2006/main">
               <a:ext uri="{FF2B5EF4-FFF2-40B4-BE49-F238E27FC236}">
-                <a16:creationId xmlns:a16="http://schemas.microsoft.com/office/drawing/2014/main" id="{17A463B9-1147-41B0-82BE-091ACEBCB8F1}"/>
+                <a16:creationId xmlns:a16="http://schemas.microsoft.com/office/drawing/2014/main" id="{75ECD95B-9DA9-4EC7-8EF4-E6B6F8DF3AD6}"/>
               </a:ext>
             </a:extLst>
           </p:cNvPr>
@@ -1301,7 +1301,7 @@
         <p:spPr>
           <a:xfrm xmlns:a="http://schemas.openxmlformats.org/drawingml/2006/main">
             <a:off x="685800" y="2009775"/>
-            <a:ext cx="10820400" cy="857250"/>
+            <a:ext cx="10820400" cy="361950"/>
           </a:xfrm>
           <a:prstGeom xmlns:a="http://schemas.openxmlformats.org/drawingml/2006/main" prst="rect">
             <a:avLst/>
@@ -1339,29 +1339,6 @@
               <a:t>20 July–18 September 2026 · 40 approved internship days</a:t>
             </a:r>
           </a:p>
-          <a:p xmlns:a="http://schemas.openxmlformats.org/drawingml/2006/main">
-            <a:pPr algn="l">
-              <a:defRPr sz="2025" b="0">
-                <a:solidFill>
-                  <a:srgbClr val="000000"/>
-                </a:solidFill>
-                <a:latin typeface="Times New Roman"/>
-                <a:ea typeface="Times New Roman"/>
-                <a:cs typeface="Times New Roman"/>
-              </a:defRPr>
-            </a:pPr>
-            <a:r>
-              <a:rPr sz="2025" b="0">
-                <a:solidFill>
-                  <a:srgbClr val="000000"/>
-                </a:solidFill>
-                <a:latin typeface="Times New Roman"/>
-                <a:ea typeface="Times New Roman"/>
-                <a:cs typeface="Times New Roman"/>
-              </a:rPr>
-              <a:t>Internship office/address: [TO COMPLETE]</a:t>
-            </a:r>
-          </a:p>
         </p:txBody>
       </p:sp>
       <p:sp>
@@ -1369,7 +1346,87 @@
           <p:cNvPr id="6" name="">
             <a:extLst xmlns:a="http://schemas.openxmlformats.org/drawingml/2006/main">
               <a:ext uri="{FF2B5EF4-FFF2-40B4-BE49-F238E27FC236}">
-                <a16:creationId xmlns:a16="http://schemas.microsoft.com/office/drawing/2014/main" id="{511DE273-4287-424B-9039-B485BD207A45}"/>
+                <a16:creationId xmlns:a16="http://schemas.microsoft.com/office/drawing/2014/main" id="{206EC2AA-113C-4627-BE16-2FDC823BDFE5}"/>
+              </a:ext>
+            </a:extLst>
+          </p:cNvPr>
+          <p:cNvSpPr>
+            <a:spLocks xmlns:a="http://schemas.openxmlformats.org/drawingml/2006/main" noGrp="1"/>
+          </p:cNvSpPr>
+          <p:nvPr/>
+        </p:nvSpPr>
+        <p:spPr>
+          <a:xfrm xmlns:a="http://schemas.openxmlformats.org/drawingml/2006/main">
+            <a:off x="685800" y="2428875"/>
+            <a:ext cx="10820400" cy="619125"/>
+          </a:xfrm>
+          <a:prstGeom xmlns:a="http://schemas.openxmlformats.org/drawingml/2006/main" prst="rect">
+            <a:avLst/>
+          </a:prstGeom>
+          <a:noFill xmlns:a="http://schemas.openxmlformats.org/drawingml/2006/main"/>
+          <a:ln xmlns:a="http://schemas.openxmlformats.org/drawingml/2006/main" w="0">
+            <a:noFill/>
+          </a:ln>
+        </p:spPr>
+        <p:txBody>
+          <a:bodyPr xmlns:a="http://schemas.openxmlformats.org/drawingml/2006/main">
+            <a:noAutofit/>
+          </a:bodyPr>
+          <a:lstStyle xmlns:a="http://schemas.openxmlformats.org/drawingml/2006/main"/>
+          <a:p xmlns:a="http://schemas.openxmlformats.org/drawingml/2006/main">
+            <a:pPr algn="l">
+              <a:defRPr sz="1800" b="0">
+                <a:solidFill>
+                  <a:srgbClr val="000000"/>
+                </a:solidFill>
+                <a:latin typeface="Times New Roman"/>
+                <a:ea typeface="Times New Roman"/>
+                <a:cs typeface="Times New Roman"/>
+              </a:defRPr>
+            </a:pPr>
+            <a:r>
+              <a:rPr sz="1800" b="0">
+                <a:solidFill>
+                  <a:srgbClr val="000000"/>
+                </a:solidFill>
+                <a:latin typeface="Times New Roman"/>
+                <a:ea typeface="Times New Roman"/>
+                <a:cs typeface="Times New Roman"/>
+              </a:rPr>
+              <a:t>Internship office: Fatih Sultan Mehmet Mah., Balkan Cad. No:49,</a:t>
+            </a:r>
+          </a:p>
+          <a:p xmlns:a="http://schemas.openxmlformats.org/drawingml/2006/main">
+            <a:pPr algn="l">
+              <a:defRPr sz="1800" b="0">
+                <a:solidFill>
+                  <a:srgbClr val="000000"/>
+                </a:solidFill>
+                <a:latin typeface="Times New Roman"/>
+                <a:ea typeface="Times New Roman"/>
+                <a:cs typeface="Times New Roman"/>
+              </a:defRPr>
+            </a:pPr>
+            <a:r>
+              <a:rPr sz="1800" b="0">
+                <a:solidFill>
+                  <a:srgbClr val="000000"/>
+                </a:solidFill>
+                <a:latin typeface="Times New Roman"/>
+                <a:ea typeface="Times New Roman"/>
+                <a:cs typeface="Times New Roman"/>
+              </a:rPr>
+              <a:t>34771 Ümraniye / İstanbul</a:t>
+            </a:r>
+          </a:p>
+        </p:txBody>
+      </p:sp>
+      <p:sp>
+        <p:nvSpPr>
+          <p:cNvPr id="7" name="">
+            <a:extLst xmlns:a="http://schemas.openxmlformats.org/drawingml/2006/main">
+              <a:ext uri="{FF2B5EF4-FFF2-40B4-BE49-F238E27FC236}">
+                <a16:creationId xmlns:a16="http://schemas.microsoft.com/office/drawing/2014/main" id="{D117F19B-58A7-4B6E-A933-C2E0A5F25272}"/>
               </a:ext>
             </a:extLst>
           </p:cNvPr>
@@ -1423,10 +1480,10 @@
       </p:sp>
       <p:sp>
         <p:nvSpPr>
-          <p:cNvPr id="7" name="">
+          <p:cNvPr id="8" name="">
             <a:extLst xmlns:a="http://schemas.openxmlformats.org/drawingml/2006/main">
               <a:ext uri="{FF2B5EF4-FFF2-40B4-BE49-F238E27FC236}">
-                <a16:creationId xmlns:a16="http://schemas.microsoft.com/office/drawing/2014/main" id="{1B32F0FE-F2C0-446C-8E11-FB0C9C5CADD1}"/>
+                <a16:creationId xmlns:a16="http://schemas.microsoft.com/office/drawing/2014/main" id="{4C7C1471-EE11-4BE1-98FD-1658A3C8BF52}"/>
               </a:ext>
             </a:extLst>
           </p:cNvPr>
@@ -1503,10 +1560,10 @@
       </p:sp>
       <p:sp>
         <p:nvSpPr>
-          <p:cNvPr id="8" name="">
+          <p:cNvPr id="9" name="">
             <a:extLst xmlns:a="http://schemas.openxmlformats.org/drawingml/2006/main">
               <a:ext uri="{FF2B5EF4-FFF2-40B4-BE49-F238E27FC236}">
-                <a16:creationId xmlns:a16="http://schemas.microsoft.com/office/drawing/2014/main" id="{93650D1C-698F-495D-8065-E96325067601}"/>
+                <a16:creationId xmlns:a16="http://schemas.microsoft.com/office/drawing/2014/main" id="{4F3924D8-4167-41FF-8438-383F246D5A2A}"/>
               </a:ext>
             </a:extLst>
           </p:cNvPr>
@@ -1560,10 +1617,10 @@
       </p:sp>
       <p:sp>
         <p:nvSpPr>
-          <p:cNvPr id="9" name="">
+          <p:cNvPr id="10" name="">
             <a:extLst xmlns:a="http://schemas.openxmlformats.org/drawingml/2006/main">
               <a:ext uri="{FF2B5EF4-FFF2-40B4-BE49-F238E27FC236}">
-                <a16:creationId xmlns:a16="http://schemas.microsoft.com/office/drawing/2014/main" id="{014F7479-612A-4385-A5D5-BF6B0137F440}"/>
+                <a16:creationId xmlns:a16="http://schemas.microsoft.com/office/drawing/2014/main" id="{ADFF7A04-C597-4FE9-A6A5-ABB1426F7DA5}"/>
               </a:ext>
             </a:extLst>
           </p:cNvPr>
@@ -1640,10 +1697,10 @@
       </p:sp>
       <p:sp>
         <p:nvSpPr>
-          <p:cNvPr id="10" name="">
+          <p:cNvPr id="11" name="">
             <a:extLst xmlns:a="http://schemas.openxmlformats.org/drawingml/2006/main">
               <a:ext uri="{FF2B5EF4-FFF2-40B4-BE49-F238E27FC236}">
-                <a16:creationId xmlns:a16="http://schemas.microsoft.com/office/drawing/2014/main" id="{57BA3E68-7F95-4997-ABF0-B28632E60BC3}"/>
+                <a16:creationId xmlns:a16="http://schemas.microsoft.com/office/drawing/2014/main" id="{4E6027DF-4886-4107-BC7B-73E22DD3EBF6}"/>
               </a:ext>
             </a:extLst>
           </p:cNvPr>
@@ -1697,10 +1754,10 @@
       </p:sp>
       <p:sp>
         <p:nvSpPr>
-          <p:cNvPr id="11" name="">
+          <p:cNvPr id="12" name="">
             <a:extLst xmlns:a="http://schemas.openxmlformats.org/drawingml/2006/main">
               <a:ext uri="{FF2B5EF4-FFF2-40B4-BE49-F238E27FC236}">
-                <a16:creationId xmlns:a16="http://schemas.microsoft.com/office/drawing/2014/main" id="{7C2870BB-AD03-4BB2-B033-BCCD075F6233}"/>
+                <a16:creationId xmlns:a16="http://schemas.microsoft.com/office/drawing/2014/main" id="{A46132C6-E880-48CC-A884-798EE1812D3B}"/>
               </a:ext>
             </a:extLst>
           </p:cNvPr>
@@ -1778,7 +1835,7 @@
     </p:spTree>
     <p:extLst>
       <p:ext uri="{BB962C8B-B14F-4D97-AF65-F5344CB8AC3E}">
-        <p14:creationId xmlns:p14="http://schemas.microsoft.com/office/powerpoint/2010/main" val="1823659372"/>
+        <p14:creationId xmlns:p14="http://schemas.microsoft.com/office/powerpoint/2010/main" val="1702727325"/>
       </p:ext>
     </p:extLst>
   </p:cSld>

</xml_diff>

<commit_message>
docs: confirm supervisor title and defer submission dates
</commit_message>
<xml_diff>
--- a/rapor/final_2026/deliverables/CS395_Digest_EfeHan_Keles_25September2026.pptx
+++ b/rapor/final_2026/deliverables/CS395_Digest_EfeHan_Keles_25September2026.pptx
@@ -2,13 +2,13 @@
 <file path=ppt/presentation.xml><?xml version="1.0" encoding="utf-8"?>
 <p:presentation xmlns:p="http://schemas.openxmlformats.org/presentationml/2006/main">
   <p:sldMasterIdLst>
-    <p:sldMasterId xmlns:r="http://schemas.openxmlformats.org/officeDocument/2006/relationships" id="2147483648" r:id="R941de56f910e498d"/>
+    <p:sldMasterId xmlns:r="http://schemas.openxmlformats.org/officeDocument/2006/relationships" id="2147483648" r:id="R21a639a9a87d4142"/>
   </p:sldMasterIdLst>
   <p:notesMasterIdLst>
-    <p:notesMasterId xmlns:r="http://schemas.openxmlformats.org/officeDocument/2006/relationships" r:id="R788d1c8eb40146e0"/>
+    <p:notesMasterId xmlns:r="http://schemas.openxmlformats.org/officeDocument/2006/relationships" r:id="Rf87b118b807443af"/>
   </p:notesMasterIdLst>
   <p:sldIdLst>
-    <p:sldId xmlns:r="http://schemas.openxmlformats.org/officeDocument/2006/relationships" id="256" r:id="Rcb1e86cd8d4c451d"/>
+    <p:sldId xmlns:r="http://schemas.openxmlformats.org/officeDocument/2006/relationships" id="256" r:id="R19872ef58fb04d49"/>
   </p:sldIdLst>
   <p:sldSz cx="12192000" cy="6858000"/>
   <p:notesSz cx="6858000" cy="9144000"/>
@@ -442,7 +442,7 @@
           <a:lstStyle xmlns:a="http://schemas.openxmlformats.org/drawingml/2006/main"/>
           <a:p xmlns:a="http://schemas.openxmlformats.org/drawingml/2006/main">
             <a:r>
-              <a:t>Standalone internship digest. Original and social-style views use the same 320 development parents: 160 real and 160 AI. Social-style means long-side cap 1080 followed by JPEG75. E92 newly missed one original AI image caught by E43, so full acceptance failed despite the numeric milestone. Model2 remains experimental. The student confirmed the internship office as Fatih Sultan Mehmet Mah., Balkan Cad. No:49, 34771 Ümraniye / İstanbul on 25 September 2026. Supervisor: Önder Çelebi. Full sources and limitations are in the report.</a:t>
+              <a:t>Standalone internship digest. Original and social-style views use the same 320 development parents: 160 real and 160 AI. Social-style means long-side cap 1080 followed by JPEG75. E92 newly missed one original AI image caught by E43, so full acceptance failed despite the numeric milestone. Model2 remains experimental. The student confirmed the internship office as Fatih Sultan Mehmet Mah., Balkan Cad. No:49, 34771 Ümraniye / İstanbul on 25 September 2026. Supervisor: Önder Çelebi, Director of the Planning and Development Directorate. Submission date: [TO COMPLETE]. Full sources and limitations are in the report.</a:t>
             </a:r>
           </a:p>
         </p:txBody>
@@ -510,7 +510,7 @@
   </p:cSld>
   <p:clrMap bg1="lt1" tx1="dk1" bg2="lt2" tx2="dk2" accent1="accent1" accent2="accent2" accent3="accent3" accent4="accent4" accent5="accent5" accent6="accent6" hlink="hlink" folHlink="folHlink"/>
   <p:sldLayoutIdLst>
-    <p:sldLayoutId xmlns:r="http://schemas.openxmlformats.org/officeDocument/2006/relationships" id="2147483649" r:id="Rd80baf28b3414adc"/>
+    <p:sldLayoutId xmlns:r="http://schemas.openxmlformats.org/officeDocument/2006/relationships" id="2147483649" r:id="Rd9e61be0d6be46f6"/>
   </p:sldLayoutIdLst>
   <p:txStyles>
     <p:titleStyle>
@@ -1058,10 +1058,10 @@
       </p:grpSpPr>
       <p:sp>
         <p:nvSpPr>
-          <p:cNvPr id="13" name="">
+          <p:cNvPr id="14" name="">
             <a:extLst xmlns:a="http://schemas.openxmlformats.org/drawingml/2006/main">
               <a:ext uri="{FF2B5EF4-FFF2-40B4-BE49-F238E27FC236}">
-                <a16:creationId xmlns:a16="http://schemas.microsoft.com/office/drawing/2014/main" id="{B260F7F2-5393-4EB8-BDA9-2CABABEC85ED}"/>
+                <a16:creationId xmlns:a16="http://schemas.microsoft.com/office/drawing/2014/main" id="{AA7D2BD2-C763-471C-A77C-876B6AB31833}"/>
               </a:ext>
             </a:extLst>
           </p:cNvPr>
@@ -1118,7 +1118,7 @@
           <p:cNvPr id="2" name="">
             <a:extLst xmlns:a="http://schemas.openxmlformats.org/drawingml/2006/main">
               <a:ext uri="{FF2B5EF4-FFF2-40B4-BE49-F238E27FC236}">
-                <a16:creationId xmlns:a16="http://schemas.microsoft.com/office/drawing/2014/main" id="{6227D0FB-EC32-4212-9A02-EF6206EE4E80}"/>
+                <a16:creationId xmlns:a16="http://schemas.microsoft.com/office/drawing/2014/main" id="{15C8F830-F9A9-4EB8-86EF-F74DE44BEA4E}"/>
               </a:ext>
             </a:extLst>
           </p:cNvPr>
@@ -1175,7 +1175,7 @@
           <p:cNvPr id="3" name="">
             <a:extLst xmlns:a="http://schemas.openxmlformats.org/drawingml/2006/main">
               <a:ext uri="{FF2B5EF4-FFF2-40B4-BE49-F238E27FC236}">
-                <a16:creationId xmlns:a16="http://schemas.microsoft.com/office/drawing/2014/main" id="{DCDEEB1D-E1EC-4E8D-B33D-21310322FAF8}"/>
+                <a16:creationId xmlns:a16="http://schemas.microsoft.com/office/drawing/2014/main" id="{335DEF6B-2FD1-4533-AD32-52D2525E67CA}"/>
               </a:ext>
             </a:extLst>
           </p:cNvPr>
@@ -1232,7 +1232,7 @@
           <p:cNvPr id="4" name="">
             <a:extLst xmlns:a="http://schemas.openxmlformats.org/drawingml/2006/main">
               <a:ext uri="{FF2B5EF4-FFF2-40B4-BE49-F238E27FC236}">
-                <a16:creationId xmlns:a16="http://schemas.microsoft.com/office/drawing/2014/main" id="{1EA3C49A-2AF9-449A-B7BB-A32692F6DF8B}"/>
+                <a16:creationId xmlns:a16="http://schemas.microsoft.com/office/drawing/2014/main" id="{BD8B91EE-F464-494A-9928-29A2F4F8D8BE}"/>
               </a:ext>
             </a:extLst>
           </p:cNvPr>
@@ -1289,7 +1289,7 @@
           <p:cNvPr id="5" name="">
             <a:extLst xmlns:a="http://schemas.openxmlformats.org/drawingml/2006/main">
               <a:ext uri="{FF2B5EF4-FFF2-40B4-BE49-F238E27FC236}">
-                <a16:creationId xmlns:a16="http://schemas.microsoft.com/office/drawing/2014/main" id="{75ECD95B-9DA9-4EC7-8EF4-E6B6F8DF3AD6}"/>
+                <a16:creationId xmlns:a16="http://schemas.microsoft.com/office/drawing/2014/main" id="{E16A51AB-EE96-4884-B673-C80BF8CC9AA1}"/>
               </a:ext>
             </a:extLst>
           </p:cNvPr>
@@ -1346,7 +1346,7 @@
           <p:cNvPr id="6" name="">
             <a:extLst xmlns:a="http://schemas.openxmlformats.org/drawingml/2006/main">
               <a:ext uri="{FF2B5EF4-FFF2-40B4-BE49-F238E27FC236}">
-                <a16:creationId xmlns:a16="http://schemas.microsoft.com/office/drawing/2014/main" id="{206EC2AA-113C-4627-BE16-2FDC823BDFE5}"/>
+                <a16:creationId xmlns:a16="http://schemas.microsoft.com/office/drawing/2014/main" id="{F9905DC5-7F31-45FE-8CCF-D7D93BECB558}"/>
               </a:ext>
             </a:extLst>
           </p:cNvPr>
@@ -1426,7 +1426,7 @@
           <p:cNvPr id="7" name="">
             <a:extLst xmlns:a="http://schemas.openxmlformats.org/drawingml/2006/main">
               <a:ext uri="{FF2B5EF4-FFF2-40B4-BE49-F238E27FC236}">
-                <a16:creationId xmlns:a16="http://schemas.microsoft.com/office/drawing/2014/main" id="{D117F19B-58A7-4B6E-A933-C2E0A5F25272}"/>
+                <a16:creationId xmlns:a16="http://schemas.microsoft.com/office/drawing/2014/main" id="{39EDC497-9944-45B3-8261-F435207A4FBC}"/>
               </a:ext>
             </a:extLst>
           </p:cNvPr>
@@ -1483,7 +1483,7 @@
           <p:cNvPr id="8" name="">
             <a:extLst xmlns:a="http://schemas.openxmlformats.org/drawingml/2006/main">
               <a:ext uri="{FF2B5EF4-FFF2-40B4-BE49-F238E27FC236}">
-                <a16:creationId xmlns:a16="http://schemas.microsoft.com/office/drawing/2014/main" id="{4C7C1471-EE11-4BE1-98FD-1658A3C8BF52}"/>
+                <a16:creationId xmlns:a16="http://schemas.microsoft.com/office/drawing/2014/main" id="{A3B5DDDA-A79C-4FC7-8D41-ACDA272E87A7}"/>
               </a:ext>
             </a:extLst>
           </p:cNvPr>
@@ -1563,7 +1563,7 @@
           <p:cNvPr id="9" name="">
             <a:extLst xmlns:a="http://schemas.openxmlformats.org/drawingml/2006/main">
               <a:ext uri="{FF2B5EF4-FFF2-40B4-BE49-F238E27FC236}">
-                <a16:creationId xmlns:a16="http://schemas.microsoft.com/office/drawing/2014/main" id="{4F3924D8-4167-41FF-8438-383F246D5A2A}"/>
+                <a16:creationId xmlns:a16="http://schemas.microsoft.com/office/drawing/2014/main" id="{400E44E6-A0CE-4F1D-B815-ED2A820810C9}"/>
               </a:ext>
             </a:extLst>
           </p:cNvPr>
@@ -1620,7 +1620,7 @@
           <p:cNvPr id="10" name="">
             <a:extLst xmlns:a="http://schemas.openxmlformats.org/drawingml/2006/main">
               <a:ext uri="{FF2B5EF4-FFF2-40B4-BE49-F238E27FC236}">
-                <a16:creationId xmlns:a16="http://schemas.microsoft.com/office/drawing/2014/main" id="{ADFF7A04-C597-4FE9-A6A5-ABB1426F7DA5}"/>
+                <a16:creationId xmlns:a16="http://schemas.microsoft.com/office/drawing/2014/main" id="{A55DBA3C-8E08-401B-A51F-C173BB9577DC}"/>
               </a:ext>
             </a:extLst>
           </p:cNvPr>
@@ -1700,7 +1700,7 @@
           <p:cNvPr id="11" name="">
             <a:extLst xmlns:a="http://schemas.openxmlformats.org/drawingml/2006/main">
               <a:ext uri="{FF2B5EF4-FFF2-40B4-BE49-F238E27FC236}">
-                <a16:creationId xmlns:a16="http://schemas.microsoft.com/office/drawing/2014/main" id="{4E6027DF-4886-4107-BC7B-73E22DD3EBF6}"/>
+                <a16:creationId xmlns:a16="http://schemas.microsoft.com/office/drawing/2014/main" id="{0A2684EF-822D-4B3C-A2D8-9B0357CA4CD2}"/>
               </a:ext>
             </a:extLst>
           </p:cNvPr>
@@ -1757,7 +1757,7 @@
           <p:cNvPr id="12" name="">
             <a:extLst xmlns:a="http://schemas.openxmlformats.org/drawingml/2006/main">
               <a:ext uri="{FF2B5EF4-FFF2-40B4-BE49-F238E27FC236}">
-                <a16:creationId xmlns:a16="http://schemas.microsoft.com/office/drawing/2014/main" id="{A46132C6-E880-48CC-A884-798EE1812D3B}"/>
+                <a16:creationId xmlns:a16="http://schemas.microsoft.com/office/drawing/2014/main" id="{5379593B-3B9C-4D97-9112-B95E931F6344}"/>
               </a:ext>
             </a:extLst>
           </p:cNvPr>
@@ -1769,7 +1769,7 @@
         <p:spPr>
           <a:xfrm xmlns:a="http://schemas.openxmlformats.org/drawingml/2006/main">
             <a:off x="3429000" y="5267325"/>
-            <a:ext cx="8048625" cy="904875"/>
+            <a:ext cx="8048625" cy="666750"/>
           </a:xfrm>
           <a:prstGeom xmlns:a="http://schemas.openxmlformats.org/drawingml/2006/main" prst="rect">
             <a:avLst/>
@@ -1832,10 +1832,67 @@
           </a:p>
         </p:txBody>
       </p:sp>
+      <p:sp>
+        <p:nvSpPr>
+          <p:cNvPr id="13" name="">
+            <a:extLst xmlns:a="http://schemas.openxmlformats.org/drawingml/2006/main">
+              <a:ext uri="{FF2B5EF4-FFF2-40B4-BE49-F238E27FC236}">
+                <a16:creationId xmlns:a16="http://schemas.microsoft.com/office/drawing/2014/main" id="{A0235FD0-DB72-4295-A20C-589F8998FF6C}"/>
+              </a:ext>
+            </a:extLst>
+          </p:cNvPr>
+          <p:cNvSpPr>
+            <a:spLocks xmlns:a="http://schemas.openxmlformats.org/drawingml/2006/main" noGrp="1"/>
+          </p:cNvSpPr>
+          <p:nvPr/>
+        </p:nvSpPr>
+        <p:spPr>
+          <a:xfrm xmlns:a="http://schemas.openxmlformats.org/drawingml/2006/main">
+            <a:off x="685800" y="5981700"/>
+            <a:ext cx="10820400" cy="266700"/>
+          </a:xfrm>
+          <a:prstGeom xmlns:a="http://schemas.openxmlformats.org/drawingml/2006/main" prst="rect">
+            <a:avLst/>
+          </a:prstGeom>
+          <a:noFill xmlns:a="http://schemas.openxmlformats.org/drawingml/2006/main"/>
+          <a:ln xmlns:a="http://schemas.openxmlformats.org/drawingml/2006/main" w="0">
+            <a:noFill/>
+          </a:ln>
+        </p:spPr>
+        <p:txBody>
+          <a:bodyPr xmlns:a="http://schemas.openxmlformats.org/drawingml/2006/main">
+            <a:noAutofit/>
+          </a:bodyPr>
+          <a:lstStyle xmlns:a="http://schemas.openxmlformats.org/drawingml/2006/main"/>
+          <a:p xmlns:a="http://schemas.openxmlformats.org/drawingml/2006/main">
+            <a:pPr algn="l">
+              <a:defRPr sz="1500" b="0">
+                <a:solidFill>
+                  <a:srgbClr val="000000"/>
+                </a:solidFill>
+                <a:latin typeface="Times New Roman"/>
+                <a:ea typeface="Times New Roman"/>
+                <a:cs typeface="Times New Roman"/>
+              </a:defRPr>
+            </a:pPr>
+            <a:r>
+              <a:rPr sz="1500" b="0">
+                <a:solidFill>
+                  <a:srgbClr val="000000"/>
+                </a:solidFill>
+                <a:latin typeface="Times New Roman"/>
+                <a:ea typeface="Times New Roman"/>
+                <a:cs typeface="Times New Roman"/>
+              </a:rPr>
+              <a:t>Supervisor: Önder Çelebi, Director · Submission date: [TO COMPLETE]</a:t>
+            </a:r>
+          </a:p>
+        </p:txBody>
+      </p:sp>
     </p:spTree>
     <p:extLst>
       <p:ext uri="{BB962C8B-B14F-4D97-AF65-F5344CB8AC3E}">
-        <p14:creationId xmlns:p14="http://schemas.microsoft.com/office/powerpoint/2010/main" val="1702727325"/>
+        <p14:creationId xmlns:p14="http://schemas.microsoft.com/office/powerpoint/2010/main" val="1260393680"/>
       </p:ext>
     </p:extLst>
   </p:cSld>

</xml_diff>

<commit_message>
Clarify report evidence and refresh internship submission package
</commit_message>
<xml_diff>
--- a/rapor/final_2026/deliverables/CS395_Digest_EfeHan_Keles_25September2026.pptx
+++ b/rapor/final_2026/deliverables/CS395_Digest_EfeHan_Keles_25September2026.pptx
@@ -2,13 +2,13 @@
 <file path=ppt/presentation.xml><?xml version="1.0" encoding="utf-8"?>
 <p:presentation xmlns:p="http://schemas.openxmlformats.org/presentationml/2006/main">
   <p:sldMasterIdLst>
-    <p:sldMasterId xmlns:r="http://schemas.openxmlformats.org/officeDocument/2006/relationships" id="2147483648" r:id="R21a639a9a87d4142"/>
+    <p:sldMasterId xmlns:r="http://schemas.openxmlformats.org/officeDocument/2006/relationships" id="2147483648" r:id="Rf44af0c99a824c00"/>
   </p:sldMasterIdLst>
   <p:notesMasterIdLst>
-    <p:notesMasterId xmlns:r="http://schemas.openxmlformats.org/officeDocument/2006/relationships" r:id="Rf87b118b807443af"/>
+    <p:notesMasterId xmlns:r="http://schemas.openxmlformats.org/officeDocument/2006/relationships" r:id="Rd1c259d8f8c64919"/>
   </p:notesMasterIdLst>
   <p:sldIdLst>
-    <p:sldId xmlns:r="http://schemas.openxmlformats.org/officeDocument/2006/relationships" id="256" r:id="R19872ef58fb04d49"/>
+    <p:sldId xmlns:r="http://schemas.openxmlformats.org/officeDocument/2006/relationships" id="256" r:id="Re39c120c63484e3f"/>
   </p:sldIdLst>
   <p:sldSz cx="12192000" cy="6858000"/>
   <p:notesSz cx="6858000" cy="9144000"/>
@@ -510,7 +510,7 @@
   </p:cSld>
   <p:clrMap bg1="lt1" tx1="dk1" bg2="lt2" tx2="dk2" accent1="accent1" accent2="accent2" accent3="accent3" accent4="accent4" accent5="accent5" accent6="accent6" hlink="hlink" folHlink="folHlink"/>
   <p:sldLayoutIdLst>
-    <p:sldLayoutId xmlns:r="http://schemas.openxmlformats.org/officeDocument/2006/relationships" id="2147483649" r:id="Rd9e61be0d6be46f6"/>
+    <p:sldLayoutId xmlns:r="http://schemas.openxmlformats.org/officeDocument/2006/relationships" id="2147483649" r:id="Recf145c4cfa643d5"/>
   </p:sldLayoutIdLst>
   <p:txStyles>
     <p:titleStyle>
@@ -1061,7 +1061,7 @@
           <p:cNvPr id="14" name="">
             <a:extLst xmlns:a="http://schemas.openxmlformats.org/drawingml/2006/main">
               <a:ext uri="{FF2B5EF4-FFF2-40B4-BE49-F238E27FC236}">
-                <a16:creationId xmlns:a16="http://schemas.microsoft.com/office/drawing/2014/main" id="{AA7D2BD2-C763-471C-A77C-876B6AB31833}"/>
+                <a16:creationId xmlns:a16="http://schemas.microsoft.com/office/drawing/2014/main" id="{BDD094B3-EB9D-458C-B591-4523D99DC62D}"/>
               </a:ext>
             </a:extLst>
           </p:cNvPr>
@@ -1118,7 +1118,7 @@
           <p:cNvPr id="2" name="">
             <a:extLst xmlns:a="http://schemas.openxmlformats.org/drawingml/2006/main">
               <a:ext uri="{FF2B5EF4-FFF2-40B4-BE49-F238E27FC236}">
-                <a16:creationId xmlns:a16="http://schemas.microsoft.com/office/drawing/2014/main" id="{15C8F830-F9A9-4EB8-86EF-F74DE44BEA4E}"/>
+                <a16:creationId xmlns:a16="http://schemas.microsoft.com/office/drawing/2014/main" id="{6A63E18D-5475-4D87-9E6A-0CA948A972EF}"/>
               </a:ext>
             </a:extLst>
           </p:cNvPr>
@@ -1175,7 +1175,7 @@
           <p:cNvPr id="3" name="">
             <a:extLst xmlns:a="http://schemas.openxmlformats.org/drawingml/2006/main">
               <a:ext uri="{FF2B5EF4-FFF2-40B4-BE49-F238E27FC236}">
-                <a16:creationId xmlns:a16="http://schemas.microsoft.com/office/drawing/2014/main" id="{335DEF6B-2FD1-4533-AD32-52D2525E67CA}"/>
+                <a16:creationId xmlns:a16="http://schemas.microsoft.com/office/drawing/2014/main" id="{D9727248-7D57-4437-B73A-515990BCE3AC}"/>
               </a:ext>
             </a:extLst>
           </p:cNvPr>
@@ -1232,7 +1232,7 @@
           <p:cNvPr id="4" name="">
             <a:extLst xmlns:a="http://schemas.openxmlformats.org/drawingml/2006/main">
               <a:ext uri="{FF2B5EF4-FFF2-40B4-BE49-F238E27FC236}">
-                <a16:creationId xmlns:a16="http://schemas.microsoft.com/office/drawing/2014/main" id="{BD8B91EE-F464-494A-9928-29A2F4F8D8BE}"/>
+                <a16:creationId xmlns:a16="http://schemas.microsoft.com/office/drawing/2014/main" id="{B20AF241-8FA2-42AA-AEC4-059A304BA118}"/>
               </a:ext>
             </a:extLst>
           </p:cNvPr>
@@ -1289,7 +1289,7 @@
           <p:cNvPr id="5" name="">
             <a:extLst xmlns:a="http://schemas.openxmlformats.org/drawingml/2006/main">
               <a:ext uri="{FF2B5EF4-FFF2-40B4-BE49-F238E27FC236}">
-                <a16:creationId xmlns:a16="http://schemas.microsoft.com/office/drawing/2014/main" id="{E16A51AB-EE96-4884-B673-C80BF8CC9AA1}"/>
+                <a16:creationId xmlns:a16="http://schemas.microsoft.com/office/drawing/2014/main" id="{BA926C58-7CA4-4368-AA4A-D77C28C31533}"/>
               </a:ext>
             </a:extLst>
           </p:cNvPr>
@@ -1346,7 +1346,7 @@
           <p:cNvPr id="6" name="">
             <a:extLst xmlns:a="http://schemas.openxmlformats.org/drawingml/2006/main">
               <a:ext uri="{FF2B5EF4-FFF2-40B4-BE49-F238E27FC236}">
-                <a16:creationId xmlns:a16="http://schemas.microsoft.com/office/drawing/2014/main" id="{F9905DC5-7F31-45FE-8CCF-D7D93BECB558}"/>
+                <a16:creationId xmlns:a16="http://schemas.microsoft.com/office/drawing/2014/main" id="{3F8CC671-1B9A-40DE-AF79-7CE5B3AA28F6}"/>
               </a:ext>
             </a:extLst>
           </p:cNvPr>
@@ -1426,7 +1426,7 @@
           <p:cNvPr id="7" name="">
             <a:extLst xmlns:a="http://schemas.openxmlformats.org/drawingml/2006/main">
               <a:ext uri="{FF2B5EF4-FFF2-40B4-BE49-F238E27FC236}">
-                <a16:creationId xmlns:a16="http://schemas.microsoft.com/office/drawing/2014/main" id="{39EDC497-9944-45B3-8261-F435207A4FBC}"/>
+                <a16:creationId xmlns:a16="http://schemas.microsoft.com/office/drawing/2014/main" id="{0C277339-B1C0-4B92-B2E1-7F5707C94710}"/>
               </a:ext>
             </a:extLst>
           </p:cNvPr>
@@ -1483,7 +1483,7 @@
           <p:cNvPr id="8" name="">
             <a:extLst xmlns:a="http://schemas.openxmlformats.org/drawingml/2006/main">
               <a:ext uri="{FF2B5EF4-FFF2-40B4-BE49-F238E27FC236}">
-                <a16:creationId xmlns:a16="http://schemas.microsoft.com/office/drawing/2014/main" id="{A3B5DDDA-A79C-4FC7-8D41-ACDA272E87A7}"/>
+                <a16:creationId xmlns:a16="http://schemas.microsoft.com/office/drawing/2014/main" id="{046AABC4-1A54-4ADE-A4D2-3A1321AD0813}"/>
               </a:ext>
             </a:extLst>
           </p:cNvPr>
@@ -1563,7 +1563,7 @@
           <p:cNvPr id="9" name="">
             <a:extLst xmlns:a="http://schemas.openxmlformats.org/drawingml/2006/main">
               <a:ext uri="{FF2B5EF4-FFF2-40B4-BE49-F238E27FC236}">
-                <a16:creationId xmlns:a16="http://schemas.microsoft.com/office/drawing/2014/main" id="{400E44E6-A0CE-4F1D-B815-ED2A820810C9}"/>
+                <a16:creationId xmlns:a16="http://schemas.microsoft.com/office/drawing/2014/main" id="{4353ED43-3E16-4B23-B838-2350418E750B}"/>
               </a:ext>
             </a:extLst>
           </p:cNvPr>
@@ -1620,7 +1620,7 @@
           <p:cNvPr id="10" name="">
             <a:extLst xmlns:a="http://schemas.openxmlformats.org/drawingml/2006/main">
               <a:ext uri="{FF2B5EF4-FFF2-40B4-BE49-F238E27FC236}">
-                <a16:creationId xmlns:a16="http://schemas.microsoft.com/office/drawing/2014/main" id="{A55DBA3C-8E08-401B-A51F-C173BB9577DC}"/>
+                <a16:creationId xmlns:a16="http://schemas.microsoft.com/office/drawing/2014/main" id="{707AB4D4-DE00-497A-8A2A-C84A512D97A2}"/>
               </a:ext>
             </a:extLst>
           </p:cNvPr>
@@ -1700,7 +1700,7 @@
           <p:cNvPr id="11" name="">
             <a:extLst xmlns:a="http://schemas.openxmlformats.org/drawingml/2006/main">
               <a:ext uri="{FF2B5EF4-FFF2-40B4-BE49-F238E27FC236}">
-                <a16:creationId xmlns:a16="http://schemas.microsoft.com/office/drawing/2014/main" id="{0A2684EF-822D-4B3C-A2D8-9B0357CA4CD2}"/>
+                <a16:creationId xmlns:a16="http://schemas.microsoft.com/office/drawing/2014/main" id="{19D0F27B-F84D-411C-89DA-C392EAF4D1FC}"/>
               </a:ext>
             </a:extLst>
           </p:cNvPr>
@@ -1711,8 +1711,8 @@
         </p:nvSpPr>
         <p:spPr>
           <a:xfrm xmlns:a="http://schemas.openxmlformats.org/drawingml/2006/main">
-            <a:off x="685800" y="5267325"/>
-            <a:ext cx="2476500" cy="476250"/>
+            <a:off x="685800" y="5095875"/>
+            <a:ext cx="2476500" cy="809625"/>
           </a:xfrm>
           <a:prstGeom xmlns:a="http://schemas.openxmlformats.org/drawingml/2006/main" prst="rect">
             <a:avLst/>
@@ -1747,7 +1747,30 @@
                 <a:ea typeface="Times New Roman"/>
                 <a:cs typeface="Times New Roman"/>
               </a:rPr>
-              <a:t>Measured result</a:t>
+              <a:t>Development</a:t>
+            </a:r>
+          </a:p>
+          <a:p xmlns:a="http://schemas.openxmlformats.org/drawingml/2006/main">
+            <a:pPr algn="l">
+              <a:defRPr sz="2250" b="1">
+                <a:solidFill>
+                  <a:srgbClr val="000000"/>
+                </a:solidFill>
+                <a:latin typeface="Times New Roman"/>
+                <a:ea typeface="Times New Roman"/>
+                <a:cs typeface="Times New Roman"/>
+              </a:defRPr>
+            </a:pPr>
+            <a:r>
+              <a:rPr sz="2250" b="1">
+                <a:solidFill>
+                  <a:srgbClr val="000000"/>
+                </a:solidFill>
+                <a:latin typeface="Times New Roman"/>
+                <a:ea typeface="Times New Roman"/>
+                <a:cs typeface="Times New Roman"/>
+              </a:rPr>
+              <a:t>result</a:t>
             </a:r>
           </a:p>
         </p:txBody>
@@ -1757,7 +1780,7 @@
           <p:cNvPr id="12" name="">
             <a:extLst xmlns:a="http://schemas.openxmlformats.org/drawingml/2006/main">
               <a:ext uri="{FF2B5EF4-FFF2-40B4-BE49-F238E27FC236}">
-                <a16:creationId xmlns:a16="http://schemas.microsoft.com/office/drawing/2014/main" id="{5379593B-3B9C-4D97-9112-B95E931F6344}"/>
+                <a16:creationId xmlns:a16="http://schemas.microsoft.com/office/drawing/2014/main" id="{788E38D5-B17D-4EF6-A4D4-187818D0F6E8}"/>
               </a:ext>
             </a:extLst>
           </p:cNvPr>
@@ -1768,8 +1791,8 @@
         </p:nvSpPr>
         <p:spPr>
           <a:xfrm xmlns:a="http://schemas.openxmlformats.org/drawingml/2006/main">
-            <a:off x="3429000" y="5267325"/>
-            <a:ext cx="8048625" cy="666750"/>
+            <a:off x="3429000" y="5095875"/>
+            <a:ext cx="8048625" cy="828675"/>
           </a:xfrm>
           <a:prstGeom xmlns:a="http://schemas.openxmlformats.org/drawingml/2006/main" prst="rect">
             <a:avLst/>
@@ -1804,7 +1827,7 @@
                 <a:ea typeface="Times New Roman"/>
                 <a:cs typeface="Times New Roman"/>
               </a:rPr>
-              <a:t>159/160 AI detected in each development view; real false alerts 0/160</a:t>
+              <a:t>Reused data: 159/160 AI detected in each condition.</a:t>
             </a:r>
           </a:p>
           <a:p xmlns:a="http://schemas.openxmlformats.org/drawingml/2006/main">
@@ -1827,7 +1850,30 @@
                 <a:ea typeface="Times New Roman"/>
                 <a:cs typeface="Times New Roman"/>
               </a:rPr>
-              <a:t>and 14/160. Numeric checks 20/20; full acceptance failed. Not universal.</a:t>
+              <a:t>Real false alerts: 0/160 original; 14/160 processed.</a:t>
+            </a:r>
+          </a:p>
+          <a:p xmlns:a="http://schemas.openxmlformats.org/drawingml/2006/main">
+            <a:pPr algn="l">
+              <a:defRPr sz="1875" b="0">
+                <a:solidFill>
+                  <a:srgbClr val="000000"/>
+                </a:solidFill>
+                <a:latin typeface="Times New Roman"/>
+                <a:ea typeface="Times New Roman"/>
+                <a:cs typeface="Times New Roman"/>
+              </a:defRPr>
+            </a:pPr>
+            <a:r>
+              <a:rPr sz="1875" b="0">
+                <a:solidFill>
+                  <a:srgbClr val="000000"/>
+                </a:solidFill>
+                <a:latin typeface="Times New Roman"/>
+                <a:ea typeface="Times New Roman"/>
+                <a:cs typeface="Times New Roman"/>
+              </a:rPr>
+              <a:t>20/20 checks; one new AI miss blocked full acceptance.</a:t>
             </a:r>
           </a:p>
         </p:txBody>
@@ -1837,7 +1883,7 @@
           <p:cNvPr id="13" name="">
             <a:extLst xmlns:a="http://schemas.openxmlformats.org/drawingml/2006/main">
               <a:ext uri="{FF2B5EF4-FFF2-40B4-BE49-F238E27FC236}">
-                <a16:creationId xmlns:a16="http://schemas.microsoft.com/office/drawing/2014/main" id="{A0235FD0-DB72-4295-A20C-589F8998FF6C}"/>
+                <a16:creationId xmlns:a16="http://schemas.microsoft.com/office/drawing/2014/main" id="{BCEBA3BE-8278-4DD9-8460-2B7E8C1265CE}"/>
               </a:ext>
             </a:extLst>
           </p:cNvPr>
@@ -1892,7 +1938,7 @@
     </p:spTree>
     <p:extLst>
       <p:ext uri="{BB962C8B-B14F-4D97-AF65-F5344CB8AC3E}">
-        <p14:creationId xmlns:p14="http://schemas.microsoft.com/office/powerpoint/2010/main" val="1260393680"/>
+        <p14:creationId xmlns:p14="http://schemas.microsoft.com/office/powerpoint/2010/main" val="226806175"/>
       </p:ext>
     </p:extLst>
   </p:cSld>

</xml_diff>

<commit_message>
docs: clarify historical decisions and training evidence in internship package
</commit_message>
<xml_diff>
--- a/rapor/final_2026/deliverables/CS395_Digest_EfeHan_Keles_25September2026.pptx
+++ b/rapor/final_2026/deliverables/CS395_Digest_EfeHan_Keles_25September2026.pptx
@@ -2,13 +2,13 @@
 <file path=ppt/presentation.xml><?xml version="1.0" encoding="utf-8"?>
 <p:presentation xmlns:p="http://schemas.openxmlformats.org/presentationml/2006/main">
   <p:sldMasterIdLst>
-    <p:sldMasterId xmlns:r="http://schemas.openxmlformats.org/officeDocument/2006/relationships" id="2147483648" r:id="Rf44af0c99a824c00"/>
+    <p:sldMasterId xmlns:r="http://schemas.openxmlformats.org/officeDocument/2006/relationships" id="2147483648" r:id="R707a7c525bd64649"/>
   </p:sldMasterIdLst>
   <p:notesMasterIdLst>
-    <p:notesMasterId xmlns:r="http://schemas.openxmlformats.org/officeDocument/2006/relationships" r:id="Rd1c259d8f8c64919"/>
+    <p:notesMasterId xmlns:r="http://schemas.openxmlformats.org/officeDocument/2006/relationships" r:id="Raa40017d5c6c4716"/>
   </p:notesMasterIdLst>
   <p:sldIdLst>
-    <p:sldId xmlns:r="http://schemas.openxmlformats.org/officeDocument/2006/relationships" id="256" r:id="Re39c120c63484e3f"/>
+    <p:sldId xmlns:r="http://schemas.openxmlformats.org/officeDocument/2006/relationships" id="256" r:id="Ra5f1027591134e91"/>
   </p:sldIdLst>
   <p:sldSz cx="12192000" cy="6858000"/>
   <p:notesSz cx="6858000" cy="9144000"/>
@@ -442,7 +442,7 @@
           <a:lstStyle xmlns:a="http://schemas.openxmlformats.org/drawingml/2006/main"/>
           <a:p xmlns:a="http://schemas.openxmlformats.org/drawingml/2006/main">
             <a:r>
-              <a:t>Standalone internship digest. Original and social-style views use the same 320 development parents: 160 real and 160 AI. Social-style means long-side cap 1080 followed by JPEG75. E92 newly missed one original AI image caught by E43, so full acceptance failed despite the numeric milestone. Model2 remains experimental. The student confirmed the internship office as Fatih Sultan Mehmet Mah., Balkan Cad. No:49, 34771 Ümraniye / İstanbul on 25 September 2026. Supervisor: Önder Çelebi, Director of the Planning and Development Directorate. Submission date: [TO COMPLETE]. Full sources and limitations are in the report.</a:t>
+              <a:t>Standalone internship digest. E92 learned adaptation used 12,269 training parents and four processing views per parent, or 49,076 views. These are distinct from the development set. Original and social-style views use the same 320 development parents: 160 real and 160 AI. Social-style means long-side cap 1080 followed by JPEG75. E92 newly missed one original AI image caught by E43, so full acceptance failed despite the numeric milestone. Model2 remains experimental. The student confirmed the internship office as Fatih Sultan Mehmet Mah., Balkan Cad. No:49, 34771 Ümraniye / İstanbul on 25 September 2026. Supervisor: Önder Çelebi, Director of the Planning and Development Directorate. Submission date: [TO COMPLETE]. Full sources and limitations are in the report.</a:t>
             </a:r>
           </a:p>
         </p:txBody>
@@ -510,7 +510,7 @@
   </p:cSld>
   <p:clrMap bg1="lt1" tx1="dk1" bg2="lt2" tx2="dk2" accent1="accent1" accent2="accent2" accent3="accent3" accent4="accent4" accent5="accent5" accent6="accent6" hlink="hlink" folHlink="folHlink"/>
   <p:sldLayoutIdLst>
-    <p:sldLayoutId xmlns:r="http://schemas.openxmlformats.org/officeDocument/2006/relationships" id="2147483649" r:id="Recf145c4cfa643d5"/>
+    <p:sldLayoutId xmlns:r="http://schemas.openxmlformats.org/officeDocument/2006/relationships" id="2147483649" r:id="Rd4b623339f914867"/>
   </p:sldLayoutIdLst>
   <p:txStyles>
     <p:titleStyle>
@@ -1061,7 +1061,7 @@
           <p:cNvPr id="14" name="">
             <a:extLst xmlns:a="http://schemas.openxmlformats.org/drawingml/2006/main">
               <a:ext uri="{FF2B5EF4-FFF2-40B4-BE49-F238E27FC236}">
-                <a16:creationId xmlns:a16="http://schemas.microsoft.com/office/drawing/2014/main" id="{BDD094B3-EB9D-458C-B591-4523D99DC62D}"/>
+                <a16:creationId xmlns:a16="http://schemas.microsoft.com/office/drawing/2014/main" id="{CACBAB51-5FA0-4685-A23D-7759A486FA58}"/>
               </a:ext>
             </a:extLst>
           </p:cNvPr>
@@ -1118,7 +1118,7 @@
           <p:cNvPr id="2" name="">
             <a:extLst xmlns:a="http://schemas.openxmlformats.org/drawingml/2006/main">
               <a:ext uri="{FF2B5EF4-FFF2-40B4-BE49-F238E27FC236}">
-                <a16:creationId xmlns:a16="http://schemas.microsoft.com/office/drawing/2014/main" id="{6A63E18D-5475-4D87-9E6A-0CA948A972EF}"/>
+                <a16:creationId xmlns:a16="http://schemas.microsoft.com/office/drawing/2014/main" id="{AED75251-B14C-4CC3-8A66-94ED7F97A836}"/>
               </a:ext>
             </a:extLst>
           </p:cNvPr>
@@ -1175,7 +1175,7 @@
           <p:cNvPr id="3" name="">
             <a:extLst xmlns:a="http://schemas.openxmlformats.org/drawingml/2006/main">
               <a:ext uri="{FF2B5EF4-FFF2-40B4-BE49-F238E27FC236}">
-                <a16:creationId xmlns:a16="http://schemas.microsoft.com/office/drawing/2014/main" id="{D9727248-7D57-4437-B73A-515990BCE3AC}"/>
+                <a16:creationId xmlns:a16="http://schemas.microsoft.com/office/drawing/2014/main" id="{5B9D3B44-2358-4CB0-A022-2B8EF4BCD2F5}"/>
               </a:ext>
             </a:extLst>
           </p:cNvPr>
@@ -1232,7 +1232,7 @@
           <p:cNvPr id="4" name="">
             <a:extLst xmlns:a="http://schemas.openxmlformats.org/drawingml/2006/main">
               <a:ext uri="{FF2B5EF4-FFF2-40B4-BE49-F238E27FC236}">
-                <a16:creationId xmlns:a16="http://schemas.microsoft.com/office/drawing/2014/main" id="{B20AF241-8FA2-42AA-AEC4-059A304BA118}"/>
+                <a16:creationId xmlns:a16="http://schemas.microsoft.com/office/drawing/2014/main" id="{E780FEC9-ADA5-4201-9F89-75905C655EFD}"/>
               </a:ext>
             </a:extLst>
           </p:cNvPr>
@@ -1289,7 +1289,7 @@
           <p:cNvPr id="5" name="">
             <a:extLst xmlns:a="http://schemas.openxmlformats.org/drawingml/2006/main">
               <a:ext uri="{FF2B5EF4-FFF2-40B4-BE49-F238E27FC236}">
-                <a16:creationId xmlns:a16="http://schemas.microsoft.com/office/drawing/2014/main" id="{BA926C58-7CA4-4368-AA4A-D77C28C31533}"/>
+                <a16:creationId xmlns:a16="http://schemas.microsoft.com/office/drawing/2014/main" id="{148D5D96-4BB7-47A9-95F2-C6156F2D8863}"/>
               </a:ext>
             </a:extLst>
           </p:cNvPr>
@@ -1346,7 +1346,7 @@
           <p:cNvPr id="6" name="">
             <a:extLst xmlns:a="http://schemas.openxmlformats.org/drawingml/2006/main">
               <a:ext uri="{FF2B5EF4-FFF2-40B4-BE49-F238E27FC236}">
-                <a16:creationId xmlns:a16="http://schemas.microsoft.com/office/drawing/2014/main" id="{3F8CC671-1B9A-40DE-AF79-7CE5B3AA28F6}"/>
+                <a16:creationId xmlns:a16="http://schemas.microsoft.com/office/drawing/2014/main" id="{59ED9F4A-FD50-423A-A631-4499220C640F}"/>
               </a:ext>
             </a:extLst>
           </p:cNvPr>
@@ -1426,7 +1426,7 @@
           <p:cNvPr id="7" name="">
             <a:extLst xmlns:a="http://schemas.openxmlformats.org/drawingml/2006/main">
               <a:ext uri="{FF2B5EF4-FFF2-40B4-BE49-F238E27FC236}">
-                <a16:creationId xmlns:a16="http://schemas.microsoft.com/office/drawing/2014/main" id="{0C277339-B1C0-4B92-B2E1-7F5707C94710}"/>
+                <a16:creationId xmlns:a16="http://schemas.microsoft.com/office/drawing/2014/main" id="{D0F8BAAB-3AA0-44F0-AF47-D333BFDB038A}"/>
               </a:ext>
             </a:extLst>
           </p:cNvPr>
@@ -1483,7 +1483,7 @@
           <p:cNvPr id="8" name="">
             <a:extLst xmlns:a="http://schemas.openxmlformats.org/drawingml/2006/main">
               <a:ext uri="{FF2B5EF4-FFF2-40B4-BE49-F238E27FC236}">
-                <a16:creationId xmlns:a16="http://schemas.microsoft.com/office/drawing/2014/main" id="{046AABC4-1A54-4ADE-A4D2-3A1321AD0813}"/>
+                <a16:creationId xmlns:a16="http://schemas.microsoft.com/office/drawing/2014/main" id="{6391FB2C-BDEB-415F-88A8-18D3706368DD}"/>
               </a:ext>
             </a:extLst>
           </p:cNvPr>
@@ -1563,7 +1563,7 @@
           <p:cNvPr id="9" name="">
             <a:extLst xmlns:a="http://schemas.openxmlformats.org/drawingml/2006/main">
               <a:ext uri="{FF2B5EF4-FFF2-40B4-BE49-F238E27FC236}">
-                <a16:creationId xmlns:a16="http://schemas.microsoft.com/office/drawing/2014/main" id="{4353ED43-3E16-4B23-B838-2350418E750B}"/>
+                <a16:creationId xmlns:a16="http://schemas.microsoft.com/office/drawing/2014/main" id="{2686B854-C13E-40AF-A92E-B13ACEB27B6B}"/>
               </a:ext>
             </a:extLst>
           </p:cNvPr>
@@ -1574,7 +1574,7 @@
         </p:nvSpPr>
         <p:spPr>
           <a:xfrm xmlns:a="http://schemas.openxmlformats.org/drawingml/2006/main">
-            <a:off x="685800" y="4238625"/>
+            <a:off x="685800" y="4048125"/>
             <a:ext cx="2476500" cy="476250"/>
           </a:xfrm>
           <a:prstGeom xmlns:a="http://schemas.openxmlformats.org/drawingml/2006/main" prst="rect">
@@ -1620,7 +1620,7 @@
           <p:cNvPr id="10" name="">
             <a:extLst xmlns:a="http://schemas.openxmlformats.org/drawingml/2006/main">
               <a:ext uri="{FF2B5EF4-FFF2-40B4-BE49-F238E27FC236}">
-                <a16:creationId xmlns:a16="http://schemas.microsoft.com/office/drawing/2014/main" id="{707AB4D4-DE00-497A-8A2A-C84A512D97A2}"/>
+                <a16:creationId xmlns:a16="http://schemas.microsoft.com/office/drawing/2014/main" id="{24339CFF-6534-4668-8964-38A88D92FFCD}"/>
               </a:ext>
             </a:extLst>
           </p:cNvPr>
@@ -1631,8 +1631,8 @@
         </p:nvSpPr>
         <p:spPr>
           <a:xfrm xmlns:a="http://schemas.openxmlformats.org/drawingml/2006/main">
-            <a:off x="3429000" y="4238625"/>
-            <a:ext cx="8048625" cy="857250"/>
+            <a:off x="3429000" y="4048125"/>
+            <a:ext cx="8048625" cy="952500"/>
           </a:xfrm>
           <a:prstGeom xmlns:a="http://schemas.openxmlformats.org/drawingml/2006/main" prst="rect">
             <a:avLst/>
@@ -1649,7 +1649,7 @@
           <a:lstStyle xmlns:a="http://schemas.openxmlformats.org/drawingml/2006/main"/>
           <a:p xmlns:a="http://schemas.openxmlformats.org/drawingml/2006/main">
             <a:pPr algn="l">
-              <a:defRPr sz="2175" b="0">
+              <a:defRPr sz="2025" b="0">
                 <a:solidFill>
                   <a:srgbClr val="000000"/>
                 </a:solidFill>
@@ -1659,7 +1659,7 @@
               </a:defRPr>
             </a:pPr>
             <a:r>
-              <a:rPr sz="2175" b="0">
+              <a:rPr sz="2025" b="0">
                 <a:solidFill>
                   <a:srgbClr val="000000"/>
                 </a:solidFill>
@@ -1667,12 +1667,12 @@
                 <a:ea typeface="Times New Roman"/>
                 <a:cs typeface="Times New Roman"/>
               </a:rPr>
-              <a:t>E92 research model, guarded local demo and traceable records.</a:t>
+              <a:t>E92 adaptation using 12,269 training images.</a:t>
             </a:r>
           </a:p>
           <a:p xmlns:a="http://schemas.openxmlformats.org/drawingml/2006/main">
             <a:pPr algn="l">
-              <a:defRPr sz="2175" b="0">
+              <a:defRPr sz="2025" b="0">
                 <a:solidFill>
                   <a:srgbClr val="000000"/>
                 </a:solidFill>
@@ -1682,7 +1682,7 @@
               </a:defRPr>
             </a:pPr>
             <a:r>
-              <a:rPr sz="2175" b="0">
+              <a:rPr sz="2025" b="0">
                 <a:solidFill>
                   <a:srgbClr val="000000"/>
                 </a:solidFill>
@@ -1690,7 +1690,30 @@
                 <a:ea typeface="Times New Roman"/>
                 <a:cs typeface="Times New Roman"/>
               </a:rPr>
-              <a:t>Experimental Model2 evaluator.</a:t>
+              <a:t>Local demo and documented experiments.</a:t>
+            </a:r>
+          </a:p>
+          <a:p xmlns:a="http://schemas.openxmlformats.org/drawingml/2006/main">
+            <a:pPr algn="l">
+              <a:defRPr sz="2025" b="0">
+                <a:solidFill>
+                  <a:srgbClr val="000000"/>
+                </a:solidFill>
+                <a:latin typeface="Times New Roman"/>
+                <a:ea typeface="Times New Roman"/>
+                <a:cs typeface="Times New Roman"/>
+              </a:defRPr>
+            </a:pPr>
+            <a:r>
+              <a:rPr sz="2025" b="0">
+                <a:solidFill>
+                  <a:srgbClr val="000000"/>
+                </a:solidFill>
+                <a:latin typeface="Times New Roman"/>
+                <a:ea typeface="Times New Roman"/>
+                <a:cs typeface="Times New Roman"/>
+              </a:rPr>
+              <a:t>Model2 localization remains experimental.</a:t>
             </a:r>
           </a:p>
         </p:txBody>
@@ -1700,7 +1723,7 @@
           <p:cNvPr id="11" name="">
             <a:extLst xmlns:a="http://schemas.openxmlformats.org/drawingml/2006/main">
               <a:ext uri="{FF2B5EF4-FFF2-40B4-BE49-F238E27FC236}">
-                <a16:creationId xmlns:a16="http://schemas.microsoft.com/office/drawing/2014/main" id="{19D0F27B-F84D-411C-89DA-C392EAF4D1FC}"/>
+                <a16:creationId xmlns:a16="http://schemas.microsoft.com/office/drawing/2014/main" id="{DAD1A2FF-5CBB-455F-930E-8C78DD0C481C}"/>
               </a:ext>
             </a:extLst>
           </p:cNvPr>
@@ -1780,7 +1803,7 @@
           <p:cNvPr id="12" name="">
             <a:extLst xmlns:a="http://schemas.openxmlformats.org/drawingml/2006/main">
               <a:ext uri="{FF2B5EF4-FFF2-40B4-BE49-F238E27FC236}">
-                <a16:creationId xmlns:a16="http://schemas.microsoft.com/office/drawing/2014/main" id="{788E38D5-B17D-4EF6-A4D4-187818D0F6E8}"/>
+                <a16:creationId xmlns:a16="http://schemas.microsoft.com/office/drawing/2014/main" id="{E9A2BC92-0EFB-463F-BC42-36CFA28219EF}"/>
               </a:ext>
             </a:extLst>
           </p:cNvPr>
@@ -1873,7 +1896,7 @@
                 <a:ea typeface="Times New Roman"/>
                 <a:cs typeface="Times New Roman"/>
               </a:rPr>
-              <a:t>20/20 checks; one new AI miss blocked full acceptance.</a:t>
+              <a:t>20/20 numerical checks; one new AI miss blocked acceptance.</a:t>
             </a:r>
           </a:p>
         </p:txBody>
@@ -1883,7 +1906,7 @@
           <p:cNvPr id="13" name="">
             <a:extLst xmlns:a="http://schemas.openxmlformats.org/drawingml/2006/main">
               <a:ext uri="{FF2B5EF4-FFF2-40B4-BE49-F238E27FC236}">
-                <a16:creationId xmlns:a16="http://schemas.microsoft.com/office/drawing/2014/main" id="{BCEBA3BE-8278-4DD9-8460-2B7E8C1265CE}"/>
+                <a16:creationId xmlns:a16="http://schemas.microsoft.com/office/drawing/2014/main" id="{C0E35F99-5531-418B-9576-93B874BE3524}"/>
               </a:ext>
             </a:extLst>
           </p:cNvPr>
@@ -1938,7 +1961,7 @@
     </p:spTree>
     <p:extLst>
       <p:ext uri="{BB962C8B-B14F-4D97-AF65-F5344CB8AC3E}">
-        <p14:creationId xmlns:p14="http://schemas.microsoft.com/office/powerpoint/2010/main" val="226806175"/>
+        <p14:creationId xmlns:p14="http://schemas.microsoft.com/office/powerpoint/2010/main" val="1288607088"/>
       </p:ext>
     </p:extLst>
   </p:cSld>

</xml_diff>

<commit_message>
docs: simplify internship package to 21 pages and ten-minute talk
</commit_message>
<xml_diff>
--- a/rapor/final_2026/deliverables/CS395_Digest_EfeHan_Keles_25September2026.pptx
+++ b/rapor/final_2026/deliverables/CS395_Digest_EfeHan_Keles_25September2026.pptx
@@ -2,13 +2,13 @@
 <file path=ppt/presentation.xml><?xml version="1.0" encoding="utf-8"?>
 <p:presentation xmlns:p="http://schemas.openxmlformats.org/presentationml/2006/main">
   <p:sldMasterIdLst>
-    <p:sldMasterId xmlns:r="http://schemas.openxmlformats.org/officeDocument/2006/relationships" id="2147483648" r:id="R707a7c525bd64649"/>
+    <p:sldMasterId xmlns:r="http://schemas.openxmlformats.org/officeDocument/2006/relationships" id="2147483648" r:id="R3725c6eaf89b4ee3"/>
   </p:sldMasterIdLst>
   <p:notesMasterIdLst>
-    <p:notesMasterId xmlns:r="http://schemas.openxmlformats.org/officeDocument/2006/relationships" r:id="Raa40017d5c6c4716"/>
+    <p:notesMasterId xmlns:r="http://schemas.openxmlformats.org/officeDocument/2006/relationships" r:id="R54e476cc1d2c4e4a"/>
   </p:notesMasterIdLst>
   <p:sldIdLst>
-    <p:sldId xmlns:r="http://schemas.openxmlformats.org/officeDocument/2006/relationships" id="256" r:id="Ra5f1027591134e91"/>
+    <p:sldId xmlns:r="http://schemas.openxmlformats.org/officeDocument/2006/relationships" id="256" r:id="R3a89232efb264f06"/>
   </p:sldIdLst>
   <p:sldSz cx="12192000" cy="6858000"/>
   <p:notesSz cx="6858000" cy="9144000"/>
@@ -442,7 +442,7 @@
           <a:lstStyle xmlns:a="http://schemas.openxmlformats.org/drawingml/2006/main"/>
           <a:p xmlns:a="http://schemas.openxmlformats.org/drawingml/2006/main">
             <a:r>
-              <a:t>Standalone internship digest. E92 learned adaptation used 12,269 training parents and four processing views per parent, or 49,076 views. These are distinct from the development set. Original and social-style views use the same 320 development parents: 160 real and 160 AI. Social-style means long-side cap 1080 followed by JPEG75. E92 newly missed one original AI image caught by E43, so full acceptance failed despite the numeric milestone. Model2 remains experimental. The student confirmed the internship office as Fatih Sultan Mehmet Mah., Balkan Cad. No:49, 34771 Ümraniye / İstanbul on 25 September 2026. Supervisor: Önder Çelebi, Director of the Planning and Development Directorate. Submission date: [TO COMPLETE]. Full sources and limitations are in the report.</a:t>
+              <a:t>Submission date: [TO COMPLETE]. Supervisor: Önder Çelebi, Director of the Planning and Development Directorate. E92 used 12,269 training parents, four views each (49,076 views). The separate but reused development set contains 160 real and 160 AI parents. Processed condition means long-side cap 1080 then JPEG75. Twenty numerical development checks passed, but E92 newly missed one original AI image detected by E43. No independent final-test success or production deployment is claimed. Model2 remains experimental. Sources: Keleş (2026), https://github.com/EfeHanKeles346/ai-image-detector/tree/497d45c, E92 evidence and E135 localization result. Student-confirmed internship information. Full sources in report Section 8.</a:t>
             </a:r>
           </a:p>
         </p:txBody>
@@ -510,7 +510,7 @@
   </p:cSld>
   <p:clrMap bg1="lt1" tx1="dk1" bg2="lt2" tx2="dk2" accent1="accent1" accent2="accent2" accent3="accent3" accent4="accent4" accent5="accent5" accent6="accent6" hlink="hlink" folHlink="folHlink"/>
   <p:sldLayoutIdLst>
-    <p:sldLayoutId xmlns:r="http://schemas.openxmlformats.org/officeDocument/2006/relationships" id="2147483649" r:id="Rd4b623339f914867"/>
+    <p:sldLayoutId xmlns:r="http://schemas.openxmlformats.org/officeDocument/2006/relationships" id="2147483649" r:id="Re4b034ca2c5b47f9"/>
   </p:sldLayoutIdLst>
   <p:txStyles>
     <p:titleStyle>
@@ -1058,10 +1058,10 @@
       </p:grpSpPr>
       <p:sp>
         <p:nvSpPr>
-          <p:cNvPr id="14" name="">
+          <p:cNvPr id="13" name="">
             <a:extLst xmlns:a="http://schemas.openxmlformats.org/drawingml/2006/main">
               <a:ext uri="{FF2B5EF4-FFF2-40B4-BE49-F238E27FC236}">
-                <a16:creationId xmlns:a16="http://schemas.microsoft.com/office/drawing/2014/main" id="{CACBAB51-5FA0-4685-A23D-7759A486FA58}"/>
+                <a16:creationId xmlns:a16="http://schemas.microsoft.com/office/drawing/2014/main" id="{40FD7C36-5F6C-42BF-8F01-6632ED02544C}"/>
               </a:ext>
             </a:extLst>
           </p:cNvPr>
@@ -1108,7 +1108,7 @@
                 <a:ea typeface="Times New Roman"/>
                 <a:cs typeface="Times New Roman"/>
               </a:rPr>
-              <a:t>1. PixelProof: AI Image Detection</a:t>
+              <a:t>1. PixelProof AI image detection</a:t>
             </a:r>
           </a:p>
         </p:txBody>
@@ -1118,7 +1118,7 @@
           <p:cNvPr id="2" name="">
             <a:extLst xmlns:a="http://schemas.openxmlformats.org/drawingml/2006/main">
               <a:ext uri="{FF2B5EF4-FFF2-40B4-BE49-F238E27FC236}">
-                <a16:creationId xmlns:a16="http://schemas.microsoft.com/office/drawing/2014/main" id="{AED75251-B14C-4CC3-8A66-94ED7F97A836}"/>
+                <a16:creationId xmlns:a16="http://schemas.microsoft.com/office/drawing/2014/main" id="{DE17EE7C-0726-47AA-BDA6-9475322E626E}"/>
               </a:ext>
             </a:extLst>
           </p:cNvPr>
@@ -1146,26 +1146,8 @@
           </a:bodyPr>
           <a:lstStyle xmlns:a="http://schemas.openxmlformats.org/drawingml/2006/main"/>
           <a:p xmlns:a="http://schemas.openxmlformats.org/drawingml/2006/main">
-            <a:pPr algn="l">
-              <a:defRPr sz="1350" b="0">
-                <a:solidFill>
-                  <a:srgbClr val="000000"/>
-                </a:solidFill>
-                <a:latin typeface="Times New Roman"/>
-                <a:ea typeface="Times New Roman"/>
-                <a:cs typeface="Times New Roman"/>
-              </a:defRPr>
-            </a:pPr>
             <a:r>
-              <a:rPr sz="1350" b="0">
-                <a:solidFill>
-                  <a:srgbClr val="000000"/>
-                </a:solidFill>
-                <a:latin typeface="Times New Roman"/>
-                <a:ea typeface="Times New Roman"/>
-                <a:cs typeface="Times New Roman"/>
-              </a:rPr>
-              <a:t>CS395 digest · source snapshot 497d45c · research prototype</a:t>
+              <a:t/>
             </a:r>
           </a:p>
         </p:txBody>
@@ -1175,7 +1157,7 @@
           <p:cNvPr id="3" name="">
             <a:extLst xmlns:a="http://schemas.openxmlformats.org/drawingml/2006/main">
               <a:ext uri="{FF2B5EF4-FFF2-40B4-BE49-F238E27FC236}">
-                <a16:creationId xmlns:a16="http://schemas.microsoft.com/office/drawing/2014/main" id="{5B9D3B44-2358-4CB0-A022-2B8EF4BCD2F5}"/>
+                <a16:creationId xmlns:a16="http://schemas.microsoft.com/office/drawing/2014/main" id="{5CC2FAD1-B820-4C6F-90F8-C8B3F4457152}"/>
               </a:ext>
             </a:extLst>
           </p:cNvPr>
@@ -1232,7 +1214,7 @@
           <p:cNvPr id="4" name="">
             <a:extLst xmlns:a="http://schemas.openxmlformats.org/drawingml/2006/main">
               <a:ext uri="{FF2B5EF4-FFF2-40B4-BE49-F238E27FC236}">
-                <a16:creationId xmlns:a16="http://schemas.microsoft.com/office/drawing/2014/main" id="{E780FEC9-ADA5-4201-9F89-75905C655EFD}"/>
+                <a16:creationId xmlns:a16="http://schemas.microsoft.com/office/drawing/2014/main" id="{DB8511A7-4023-4B36-B7A3-3BCCE92BC2DE}"/>
               </a:ext>
             </a:extLst>
           </p:cNvPr>
@@ -1243,8 +1225,8 @@
         </p:nvSpPr>
         <p:spPr>
           <a:xfrm xmlns:a="http://schemas.openxmlformats.org/drawingml/2006/main">
-            <a:off x="685800" y="1400175"/>
-            <a:ext cx="10820400" cy="523875"/>
+            <a:off x="685800" y="1362075"/>
+            <a:ext cx="10820400" cy="781050"/>
           </a:xfrm>
           <a:prstGeom xmlns:a="http://schemas.openxmlformats.org/drawingml/2006/main" prst="rect">
             <a:avLst/>
@@ -1279,7 +1261,30 @@
                 <a:ea typeface="Times New Roman"/>
                 <a:cs typeface="Times New Roman"/>
               </a:rPr>
-              <a:t>Türk Telekom · Efe Han Keleş · Computer Science and Engineering</a:t>
+              <a:t>Türk Telekom</a:t>
+            </a:r>
+          </a:p>
+          <a:p xmlns:a="http://schemas.openxmlformats.org/drawingml/2006/main">
+            <a:pPr algn="l">
+              <a:defRPr sz="2175" b="1">
+                <a:solidFill>
+                  <a:srgbClr val="000000"/>
+                </a:solidFill>
+                <a:latin typeface="Times New Roman"/>
+                <a:ea typeface="Times New Roman"/>
+                <a:cs typeface="Times New Roman"/>
+              </a:defRPr>
+            </a:pPr>
+            <a:r>
+              <a:rPr sz="2175" b="1">
+                <a:solidFill>
+                  <a:srgbClr val="000000"/>
+                </a:solidFill>
+                <a:latin typeface="Times New Roman"/>
+                <a:ea typeface="Times New Roman"/>
+                <a:cs typeface="Times New Roman"/>
+              </a:rPr>
+              <a:t>Efe Han Keleş, Computer Science and Engineering</a:t>
             </a:r>
           </a:p>
         </p:txBody>
@@ -1289,7 +1294,7 @@
           <p:cNvPr id="5" name="">
             <a:extLst xmlns:a="http://schemas.openxmlformats.org/drawingml/2006/main">
               <a:ext uri="{FF2B5EF4-FFF2-40B4-BE49-F238E27FC236}">
-                <a16:creationId xmlns:a16="http://schemas.microsoft.com/office/drawing/2014/main" id="{148D5D96-4BB7-47A9-95F2-C6156F2D8863}"/>
+                <a16:creationId xmlns:a16="http://schemas.microsoft.com/office/drawing/2014/main" id="{110BE177-BC06-4B00-89E2-D42D559D9825}"/>
               </a:ext>
             </a:extLst>
           </p:cNvPr>
@@ -1300,8 +1305,282 @@
         </p:nvSpPr>
         <p:spPr>
           <a:xfrm xmlns:a="http://schemas.openxmlformats.org/drawingml/2006/main">
-            <a:off x="685800" y="2009775"/>
-            <a:ext cx="10820400" cy="361950"/>
+            <a:off x="685800" y="2238375"/>
+            <a:ext cx="10820400" cy="733425"/>
+          </a:xfrm>
+          <a:prstGeom xmlns:a="http://schemas.openxmlformats.org/drawingml/2006/main" prst="rect">
+            <a:avLst/>
+          </a:prstGeom>
+          <a:noFill xmlns:a="http://schemas.openxmlformats.org/drawingml/2006/main"/>
+          <a:ln xmlns:a="http://schemas.openxmlformats.org/drawingml/2006/main" w="0">
+            <a:noFill/>
+          </a:ln>
+        </p:spPr>
+        <p:txBody>
+          <a:bodyPr xmlns:a="http://schemas.openxmlformats.org/drawingml/2006/main">
+            <a:noAutofit/>
+          </a:bodyPr>
+          <a:lstStyle xmlns:a="http://schemas.openxmlformats.org/drawingml/2006/main"/>
+          <a:p xmlns:a="http://schemas.openxmlformats.org/drawingml/2006/main">
+            <a:pPr algn="l">
+              <a:defRPr sz="1875" b="0">
+                <a:solidFill>
+                  <a:srgbClr val="000000"/>
+                </a:solidFill>
+                <a:latin typeface="Times New Roman"/>
+                <a:ea typeface="Times New Roman"/>
+                <a:cs typeface="Times New Roman"/>
+              </a:defRPr>
+            </a:pPr>
+            <a:r>
+              <a:rPr sz="1875" b="0">
+                <a:solidFill>
+                  <a:srgbClr val="000000"/>
+                </a:solidFill>
+                <a:latin typeface="Times New Roman"/>
+                <a:ea typeface="Times New Roman"/>
+                <a:cs typeface="Times New Roman"/>
+              </a:rPr>
+              <a:t>20 July–18 September 2026, 40 approved internship days</a:t>
+            </a:r>
+          </a:p>
+          <a:p xmlns:a="http://schemas.openxmlformats.org/drawingml/2006/main">
+            <a:pPr algn="l">
+              <a:defRPr sz="1875" b="0">
+                <a:solidFill>
+                  <a:srgbClr val="000000"/>
+                </a:solidFill>
+                <a:latin typeface="Times New Roman"/>
+                <a:ea typeface="Times New Roman"/>
+                <a:cs typeface="Times New Roman"/>
+              </a:defRPr>
+            </a:pPr>
+            <a:r>
+              <a:rPr sz="1875" b="0">
+                <a:solidFill>
+                  <a:srgbClr val="000000"/>
+                </a:solidFill>
+                <a:latin typeface="Times New Roman"/>
+                <a:ea typeface="Times New Roman"/>
+                <a:cs typeface="Times New Roman"/>
+              </a:rPr>
+              <a:t>Fatih Sultan Mehmet Mah., Balkan Cad. No:49, 34771 Ümraniye / İstanbul</a:t>
+            </a:r>
+          </a:p>
+        </p:txBody>
+      </p:sp>
+      <p:sp>
+        <p:nvSpPr>
+          <p:cNvPr id="6" name="">
+            <a:extLst xmlns:a="http://schemas.openxmlformats.org/drawingml/2006/main">
+              <a:ext uri="{FF2B5EF4-FFF2-40B4-BE49-F238E27FC236}">
+                <a16:creationId xmlns:a16="http://schemas.microsoft.com/office/drawing/2014/main" id="{79109418-3171-49EE-B5B9-EC0E1306CC9C}"/>
+              </a:ext>
+            </a:extLst>
+          </p:cNvPr>
+          <p:cNvSpPr>
+            <a:spLocks xmlns:a="http://schemas.openxmlformats.org/drawingml/2006/main" noGrp="1"/>
+          </p:cNvSpPr>
+          <p:nvPr/>
+        </p:nvSpPr>
+        <p:spPr>
+          <a:xfrm xmlns:a="http://schemas.openxmlformats.org/drawingml/2006/main">
+            <a:off x="685800" y="3200400"/>
+            <a:ext cx="2381250" cy="457200"/>
+          </a:xfrm>
+          <a:prstGeom xmlns:a="http://schemas.openxmlformats.org/drawingml/2006/main" prst="rect">
+            <a:avLst/>
+          </a:prstGeom>
+          <a:noFill xmlns:a="http://schemas.openxmlformats.org/drawingml/2006/main"/>
+          <a:ln xmlns:a="http://schemas.openxmlformats.org/drawingml/2006/main" w="0">
+            <a:noFill/>
+          </a:ln>
+        </p:spPr>
+        <p:txBody>
+          <a:bodyPr xmlns:a="http://schemas.openxmlformats.org/drawingml/2006/main">
+            <a:noAutofit/>
+          </a:bodyPr>
+          <a:lstStyle xmlns:a="http://schemas.openxmlformats.org/drawingml/2006/main"/>
+          <a:p xmlns:a="http://schemas.openxmlformats.org/drawingml/2006/main">
+            <a:pPr algn="l">
+              <a:defRPr sz="2325" b="1">
+                <a:solidFill>
+                  <a:srgbClr val="000000"/>
+                </a:solidFill>
+                <a:latin typeface="Times New Roman"/>
+                <a:ea typeface="Times New Roman"/>
+                <a:cs typeface="Times New Roman"/>
+              </a:defRPr>
+            </a:pPr>
+            <a:r>
+              <a:rPr sz="2325" b="1">
+                <a:solidFill>
+                  <a:srgbClr val="000000"/>
+                </a:solidFill>
+                <a:latin typeface="Times New Roman"/>
+                <a:ea typeface="Times New Roman"/>
+                <a:cs typeface="Times New Roman"/>
+              </a:rPr>
+              <a:t>Objective</a:t>
+            </a:r>
+          </a:p>
+        </p:txBody>
+      </p:sp>
+      <p:sp>
+        <p:nvSpPr>
+          <p:cNvPr id="7" name="">
+            <a:extLst xmlns:a="http://schemas.openxmlformats.org/drawingml/2006/main">
+              <a:ext uri="{FF2B5EF4-FFF2-40B4-BE49-F238E27FC236}">
+                <a16:creationId xmlns:a16="http://schemas.microsoft.com/office/drawing/2014/main" id="{629F8D7D-DDE0-4E54-81B4-9AA0D76B6E2B}"/>
+              </a:ext>
+            </a:extLst>
+          </p:cNvPr>
+          <p:cNvSpPr>
+            <a:spLocks xmlns:a="http://schemas.openxmlformats.org/drawingml/2006/main" noGrp="1"/>
+          </p:cNvSpPr>
+          <p:nvPr/>
+        </p:nvSpPr>
+        <p:spPr>
+          <a:xfrm xmlns:a="http://schemas.openxmlformats.org/drawingml/2006/main">
+            <a:off x="3286125" y="3200400"/>
+            <a:ext cx="8239125" cy="819150"/>
+          </a:xfrm>
+          <a:prstGeom xmlns:a="http://schemas.openxmlformats.org/drawingml/2006/main" prst="rect">
+            <a:avLst/>
+          </a:prstGeom>
+          <a:noFill xmlns:a="http://schemas.openxmlformats.org/drawingml/2006/main"/>
+          <a:ln xmlns:a="http://schemas.openxmlformats.org/drawingml/2006/main" w="0">
+            <a:noFill/>
+          </a:ln>
+        </p:spPr>
+        <p:txBody>
+          <a:bodyPr xmlns:a="http://schemas.openxmlformats.org/drawingml/2006/main">
+            <a:noAutofit/>
+          </a:bodyPr>
+          <a:lstStyle xmlns:a="http://schemas.openxmlformats.org/drawingml/2006/main"/>
+          <a:p xmlns:a="http://schemas.openxmlformats.org/drawingml/2006/main">
+            <a:pPr algn="l">
+              <a:defRPr sz="2175" b="0">
+                <a:solidFill>
+                  <a:srgbClr val="000000"/>
+                </a:solidFill>
+                <a:latin typeface="Times New Roman"/>
+                <a:ea typeface="Times New Roman"/>
+                <a:cs typeface="Times New Roman"/>
+              </a:defRPr>
+            </a:pPr>
+            <a:r>
+              <a:rPr sz="2175" b="0">
+                <a:solidFill>
+                  <a:srgbClr val="000000"/>
+                </a:solidFill>
+                <a:latin typeface="Times New Roman"/>
+                <a:ea typeface="Times New Roman"/>
+                <a:cs typeface="Times New Roman"/>
+              </a:rPr>
+              <a:t>Reduce false AI warnings on real photographs</a:t>
+            </a:r>
+          </a:p>
+          <a:p xmlns:a="http://schemas.openxmlformats.org/drawingml/2006/main">
+            <a:pPr algn="l">
+              <a:defRPr sz="2175" b="0">
+                <a:solidFill>
+                  <a:srgbClr val="000000"/>
+                </a:solidFill>
+                <a:latin typeface="Times New Roman"/>
+                <a:ea typeface="Times New Roman"/>
+                <a:cs typeface="Times New Roman"/>
+              </a:defRPr>
+            </a:pPr>
+            <a:r>
+              <a:rPr sz="2175" b="0">
+                <a:solidFill>
+                  <a:srgbClr val="000000"/>
+                </a:solidFill>
+                <a:latin typeface="Times New Roman"/>
+                <a:ea typeface="Times New Roman"/>
+                <a:cs typeface="Times New Roman"/>
+              </a:rPr>
+              <a:t>while preserving AI detection. Explore local AI edits.</a:t>
+            </a:r>
+          </a:p>
+        </p:txBody>
+      </p:sp>
+      <p:sp>
+        <p:nvSpPr>
+          <p:cNvPr id="8" name="">
+            <a:extLst xmlns:a="http://schemas.openxmlformats.org/drawingml/2006/main">
+              <a:ext uri="{FF2B5EF4-FFF2-40B4-BE49-F238E27FC236}">
+                <a16:creationId xmlns:a16="http://schemas.microsoft.com/office/drawing/2014/main" id="{E0284864-07F7-4880-AAC1-893F9E2FF601}"/>
+              </a:ext>
+            </a:extLst>
+          </p:cNvPr>
+          <p:cNvSpPr>
+            <a:spLocks xmlns:a="http://schemas.openxmlformats.org/drawingml/2006/main" noGrp="1"/>
+          </p:cNvSpPr>
+          <p:nvPr/>
+        </p:nvSpPr>
+        <p:spPr>
+          <a:xfrm xmlns:a="http://schemas.openxmlformats.org/drawingml/2006/main">
+            <a:off x="685800" y="4171950"/>
+            <a:ext cx="2381250" cy="457200"/>
+          </a:xfrm>
+          <a:prstGeom xmlns:a="http://schemas.openxmlformats.org/drawingml/2006/main" prst="rect">
+            <a:avLst/>
+          </a:prstGeom>
+          <a:noFill xmlns:a="http://schemas.openxmlformats.org/drawingml/2006/main"/>
+          <a:ln xmlns:a="http://schemas.openxmlformats.org/drawingml/2006/main" w="0">
+            <a:noFill/>
+          </a:ln>
+        </p:spPr>
+        <p:txBody>
+          <a:bodyPr xmlns:a="http://schemas.openxmlformats.org/drawingml/2006/main">
+            <a:noAutofit/>
+          </a:bodyPr>
+          <a:lstStyle xmlns:a="http://schemas.openxmlformats.org/drawingml/2006/main"/>
+          <a:p xmlns:a="http://schemas.openxmlformats.org/drawingml/2006/main">
+            <a:pPr algn="l">
+              <a:defRPr sz="2325" b="1">
+                <a:solidFill>
+                  <a:srgbClr val="000000"/>
+                </a:solidFill>
+                <a:latin typeface="Times New Roman"/>
+                <a:ea typeface="Times New Roman"/>
+                <a:cs typeface="Times New Roman"/>
+              </a:defRPr>
+            </a:pPr>
+            <a:r>
+              <a:rPr sz="2325" b="1">
+                <a:solidFill>
+                  <a:srgbClr val="000000"/>
+                </a:solidFill>
+                <a:latin typeface="Times New Roman"/>
+                <a:ea typeface="Times New Roman"/>
+                <a:cs typeface="Times New Roman"/>
+              </a:rPr>
+              <a:t>Outcome</a:t>
+            </a:r>
+          </a:p>
+        </p:txBody>
+      </p:sp>
+      <p:sp>
+        <p:nvSpPr>
+          <p:cNvPr id="9" name="">
+            <a:extLst xmlns:a="http://schemas.openxmlformats.org/drawingml/2006/main">
+              <a:ext uri="{FF2B5EF4-FFF2-40B4-BE49-F238E27FC236}">
+                <a16:creationId xmlns:a16="http://schemas.microsoft.com/office/drawing/2014/main" id="{0C3FBB3E-CC66-4F86-8983-EDD7FB936078}"/>
+              </a:ext>
+            </a:extLst>
+          </p:cNvPr>
+          <p:cNvSpPr>
+            <a:spLocks xmlns:a="http://schemas.openxmlformats.org/drawingml/2006/main" noGrp="1"/>
+          </p:cNvSpPr>
+          <p:nvPr/>
+        </p:nvSpPr>
+        <p:spPr>
+          <a:xfrm xmlns:a="http://schemas.openxmlformats.org/drawingml/2006/main">
+            <a:off x="3286125" y="4171950"/>
+            <a:ext cx="8239125" cy="1123950"/>
           </a:xfrm>
           <a:prstGeom xmlns:a="http://schemas.openxmlformats.org/drawingml/2006/main" prst="rect">
             <a:avLst/>
@@ -1336,17 +1615,63 @@
                 <a:ea typeface="Times New Roman"/>
                 <a:cs typeface="Times New Roman"/>
               </a:rPr>
-              <a:t>20 July–18 September 2026 · 40 approved internship days</a:t>
+              <a:t>Working local demo and documented experiments.</a:t>
+            </a:r>
+          </a:p>
+          <a:p xmlns:a="http://schemas.openxmlformats.org/drawingml/2006/main">
+            <a:pPr algn="l">
+              <a:defRPr sz="2025" b="0">
+                <a:solidFill>
+                  <a:srgbClr val="000000"/>
+                </a:solidFill>
+                <a:latin typeface="Times New Roman"/>
+                <a:ea typeface="Times New Roman"/>
+                <a:cs typeface="Times New Roman"/>
+              </a:defRPr>
+            </a:pPr>
+            <a:r>
+              <a:rPr sz="2025" b="0">
+                <a:solidFill>
+                  <a:srgbClr val="000000"/>
+                </a:solidFill>
+                <a:latin typeface="Times New Roman"/>
+                <a:ea typeface="Times New Roman"/>
+                <a:cs typeface="Times New Roman"/>
+              </a:rPr>
+              <a:t>On reused development data: 159/160 AI detected per condition.</a:t>
+            </a:r>
+          </a:p>
+          <a:p xmlns:a="http://schemas.openxmlformats.org/drawingml/2006/main">
+            <a:pPr algn="l">
+              <a:defRPr sz="2025" b="0">
+                <a:solidFill>
+                  <a:srgbClr val="000000"/>
+                </a:solidFill>
+                <a:latin typeface="Times New Roman"/>
+                <a:ea typeface="Times New Roman"/>
+                <a:cs typeface="Times New Roman"/>
+              </a:defRPr>
+            </a:pPr>
+            <a:r>
+              <a:rPr sz="2025" b="0">
+                <a:solidFill>
+                  <a:srgbClr val="000000"/>
+                </a:solidFill>
+                <a:latin typeface="Times New Roman"/>
+                <a:ea typeface="Times New Roman"/>
+                <a:cs typeface="Times New Roman"/>
+              </a:rPr>
+              <a:t>Real false warnings: 0/160 original, 14/160 after processing.</a:t>
             </a:r>
           </a:p>
         </p:txBody>
       </p:sp>
       <p:sp>
         <p:nvSpPr>
-          <p:cNvPr id="6" name="">
+          <p:cNvPr id="10" name="">
             <a:extLst xmlns:a="http://schemas.openxmlformats.org/drawingml/2006/main">
               <a:ext uri="{FF2B5EF4-FFF2-40B4-BE49-F238E27FC236}">
-                <a16:creationId xmlns:a16="http://schemas.microsoft.com/office/drawing/2014/main" id="{59ED9F4A-FD50-423A-A631-4499220C640F}"/>
+                <a16:creationId xmlns:a16="http://schemas.microsoft.com/office/drawing/2014/main" id="{8B1F3599-C74B-4301-A485-AC43242EF756}"/>
               </a:ext>
             </a:extLst>
           </p:cNvPr>
@@ -1357,8 +1682,8 @@
         </p:nvSpPr>
         <p:spPr>
           <a:xfrm xmlns:a="http://schemas.openxmlformats.org/drawingml/2006/main">
-            <a:off x="685800" y="2428875"/>
-            <a:ext cx="10820400" cy="619125"/>
+            <a:off x="685800" y="5429250"/>
+            <a:ext cx="2381250" cy="428625"/>
           </a:xfrm>
           <a:prstGeom xmlns:a="http://schemas.openxmlformats.org/drawingml/2006/main" prst="rect">
             <a:avLst/>
@@ -1375,7 +1700,7 @@
           <a:lstStyle xmlns:a="http://schemas.openxmlformats.org/drawingml/2006/main"/>
           <a:p xmlns:a="http://schemas.openxmlformats.org/drawingml/2006/main">
             <a:pPr algn="l">
-              <a:defRPr sz="1800" b="0">
+              <a:defRPr sz="2325" b="1">
                 <a:solidFill>
                   <a:srgbClr val="000000"/>
                 </a:solidFill>
@@ -1385,7 +1710,7 @@
               </a:defRPr>
             </a:pPr>
             <a:r>
-              <a:rPr sz="1800" b="0">
+              <a:rPr sz="2325" b="1">
                 <a:solidFill>
                   <a:srgbClr val="000000"/>
                 </a:solidFill>
@@ -1393,40 +1718,17 @@
                 <a:ea typeface="Times New Roman"/>
                 <a:cs typeface="Times New Roman"/>
               </a:rPr>
-              <a:t>Internship office: Fatih Sultan Mehmet Mah., Balkan Cad. No:49,</a:t>
-            </a:r>
-          </a:p>
-          <a:p xmlns:a="http://schemas.openxmlformats.org/drawingml/2006/main">
-            <a:pPr algn="l">
-              <a:defRPr sz="1800" b="0">
-                <a:solidFill>
-                  <a:srgbClr val="000000"/>
-                </a:solidFill>
-                <a:latin typeface="Times New Roman"/>
-                <a:ea typeface="Times New Roman"/>
-                <a:cs typeface="Times New Roman"/>
-              </a:defRPr>
-            </a:pPr>
-            <a:r>
-              <a:rPr sz="1800" b="0">
-                <a:solidFill>
-                  <a:srgbClr val="000000"/>
-                </a:solidFill>
-                <a:latin typeface="Times New Roman"/>
-                <a:ea typeface="Times New Roman"/>
-                <a:cs typeface="Times New Roman"/>
-              </a:rPr>
-              <a:t>34771 Ümraniye / İstanbul</a:t>
+              <a:t>Limit</a:t>
             </a:r>
           </a:p>
         </p:txBody>
       </p:sp>
       <p:sp>
         <p:nvSpPr>
-          <p:cNvPr id="7" name="">
+          <p:cNvPr id="11" name="">
             <a:extLst xmlns:a="http://schemas.openxmlformats.org/drawingml/2006/main">
               <a:ext uri="{FF2B5EF4-FFF2-40B4-BE49-F238E27FC236}">
-                <a16:creationId xmlns:a16="http://schemas.microsoft.com/office/drawing/2014/main" id="{D0F8BAAB-3AA0-44F0-AF47-D333BFDB038A}"/>
+                <a16:creationId xmlns:a16="http://schemas.microsoft.com/office/drawing/2014/main" id="{1A532B57-7CE4-45CC-91C1-3BE12F1FBCA1}"/>
               </a:ext>
             </a:extLst>
           </p:cNvPr>
@@ -1437,202 +1739,8 @@
         </p:nvSpPr>
         <p:spPr>
           <a:xfrm xmlns:a="http://schemas.openxmlformats.org/drawingml/2006/main">
-            <a:off x="685800" y="3124200"/>
-            <a:ext cx="2476500" cy="476250"/>
-          </a:xfrm>
-          <a:prstGeom xmlns:a="http://schemas.openxmlformats.org/drawingml/2006/main" prst="rect">
-            <a:avLst/>
-          </a:prstGeom>
-          <a:noFill xmlns:a="http://schemas.openxmlformats.org/drawingml/2006/main"/>
-          <a:ln xmlns:a="http://schemas.openxmlformats.org/drawingml/2006/main" w="0">
-            <a:noFill/>
-          </a:ln>
-        </p:spPr>
-        <p:txBody>
-          <a:bodyPr xmlns:a="http://schemas.openxmlformats.org/drawingml/2006/main">
-            <a:noAutofit/>
-          </a:bodyPr>
-          <a:lstStyle xmlns:a="http://schemas.openxmlformats.org/drawingml/2006/main"/>
-          <a:p xmlns:a="http://schemas.openxmlformats.org/drawingml/2006/main">
-            <a:pPr algn="l">
-              <a:defRPr sz="2250" b="1">
-                <a:solidFill>
-                  <a:srgbClr val="000000"/>
-                </a:solidFill>
-                <a:latin typeface="Times New Roman"/>
-                <a:ea typeface="Times New Roman"/>
-                <a:cs typeface="Times New Roman"/>
-              </a:defRPr>
-            </a:pPr>
-            <a:r>
-              <a:rPr sz="2250" b="1">
-                <a:solidFill>
-                  <a:srgbClr val="000000"/>
-                </a:solidFill>
-                <a:latin typeface="Times New Roman"/>
-                <a:ea typeface="Times New Roman"/>
-                <a:cs typeface="Times New Roman"/>
-              </a:rPr>
-              <a:t>Objective</a:t>
-            </a:r>
-          </a:p>
-        </p:txBody>
-      </p:sp>
-      <p:sp>
-        <p:nvSpPr>
-          <p:cNvPr id="8" name="">
-            <a:extLst xmlns:a="http://schemas.openxmlformats.org/drawingml/2006/main">
-              <a:ext uri="{FF2B5EF4-FFF2-40B4-BE49-F238E27FC236}">
-                <a16:creationId xmlns:a16="http://schemas.microsoft.com/office/drawing/2014/main" id="{6391FB2C-BDEB-415F-88A8-18D3706368DD}"/>
-              </a:ext>
-            </a:extLst>
-          </p:cNvPr>
-          <p:cNvSpPr>
-            <a:spLocks xmlns:a="http://schemas.openxmlformats.org/drawingml/2006/main" noGrp="1"/>
-          </p:cNvSpPr>
-          <p:nvPr/>
-        </p:nvSpPr>
-        <p:spPr>
-          <a:xfrm xmlns:a="http://schemas.openxmlformats.org/drawingml/2006/main">
-            <a:off x="3429000" y="3124200"/>
-            <a:ext cx="8048625" cy="857250"/>
-          </a:xfrm>
-          <a:prstGeom xmlns:a="http://schemas.openxmlformats.org/drawingml/2006/main" prst="rect">
-            <a:avLst/>
-          </a:prstGeom>
-          <a:noFill xmlns:a="http://schemas.openxmlformats.org/drawingml/2006/main"/>
-          <a:ln xmlns:a="http://schemas.openxmlformats.org/drawingml/2006/main" w="0">
-            <a:noFill/>
-          </a:ln>
-        </p:spPr>
-        <p:txBody>
-          <a:bodyPr xmlns:a="http://schemas.openxmlformats.org/drawingml/2006/main">
-            <a:noAutofit/>
-          </a:bodyPr>
-          <a:lstStyle xmlns:a="http://schemas.openxmlformats.org/drawingml/2006/main"/>
-          <a:p xmlns:a="http://schemas.openxmlformats.org/drawingml/2006/main">
-            <a:pPr algn="l">
-              <a:defRPr sz="2175" b="0">
-                <a:solidFill>
-                  <a:srgbClr val="000000"/>
-                </a:solidFill>
-                <a:latin typeface="Times New Roman"/>
-                <a:ea typeface="Times New Roman"/>
-                <a:cs typeface="Times New Roman"/>
-              </a:defRPr>
-            </a:pPr>
-            <a:r>
-              <a:rPr sz="2175" b="0">
-                <a:solidFill>
-                  <a:srgbClr val="000000"/>
-                </a:solidFill>
-                <a:latin typeface="Times New Roman"/>
-                <a:ea typeface="Times New Roman"/>
-                <a:cs typeface="Times New Roman"/>
-              </a:rPr>
-              <a:t>Detect AI-image evidence while reducing false alerts;</a:t>
-            </a:r>
-          </a:p>
-          <a:p xmlns:a="http://schemas.openxmlformats.org/drawingml/2006/main">
-            <a:pPr algn="l">
-              <a:defRPr sz="2175" b="0">
-                <a:solidFill>
-                  <a:srgbClr val="000000"/>
-                </a:solidFill>
-                <a:latin typeface="Times New Roman"/>
-                <a:ea typeface="Times New Roman"/>
-                <a:cs typeface="Times New Roman"/>
-              </a:defRPr>
-            </a:pPr>
-            <a:r>
-              <a:rPr sz="2175" b="0">
-                <a:solidFill>
-                  <a:srgbClr val="000000"/>
-                </a:solidFill>
-                <a:latin typeface="Times New Roman"/>
-                <a:ea typeface="Times New Roman"/>
-                <a:cs typeface="Times New Roman"/>
-              </a:rPr>
-              <a:t>explore localization of AI edits.</a:t>
-            </a:r>
-          </a:p>
-        </p:txBody>
-      </p:sp>
-      <p:sp>
-        <p:nvSpPr>
-          <p:cNvPr id="9" name="">
-            <a:extLst xmlns:a="http://schemas.openxmlformats.org/drawingml/2006/main">
-              <a:ext uri="{FF2B5EF4-FFF2-40B4-BE49-F238E27FC236}">
-                <a16:creationId xmlns:a16="http://schemas.microsoft.com/office/drawing/2014/main" id="{2686B854-C13E-40AF-A92E-B13ACEB27B6B}"/>
-              </a:ext>
-            </a:extLst>
-          </p:cNvPr>
-          <p:cNvSpPr>
-            <a:spLocks xmlns:a="http://schemas.openxmlformats.org/drawingml/2006/main" noGrp="1"/>
-          </p:cNvSpPr>
-          <p:nvPr/>
-        </p:nvSpPr>
-        <p:spPr>
-          <a:xfrm xmlns:a="http://schemas.openxmlformats.org/drawingml/2006/main">
-            <a:off x="685800" y="4048125"/>
-            <a:ext cx="2476500" cy="476250"/>
-          </a:xfrm>
-          <a:prstGeom xmlns:a="http://schemas.openxmlformats.org/drawingml/2006/main" prst="rect">
-            <a:avLst/>
-          </a:prstGeom>
-          <a:noFill xmlns:a="http://schemas.openxmlformats.org/drawingml/2006/main"/>
-          <a:ln xmlns:a="http://schemas.openxmlformats.org/drawingml/2006/main" w="0">
-            <a:noFill/>
-          </a:ln>
-        </p:spPr>
-        <p:txBody>
-          <a:bodyPr xmlns:a="http://schemas.openxmlformats.org/drawingml/2006/main">
-            <a:noAutofit/>
-          </a:bodyPr>
-          <a:lstStyle xmlns:a="http://schemas.openxmlformats.org/drawingml/2006/main"/>
-          <a:p xmlns:a="http://schemas.openxmlformats.org/drawingml/2006/main">
-            <a:pPr algn="l">
-              <a:defRPr sz="2250" b="1">
-                <a:solidFill>
-                  <a:srgbClr val="000000"/>
-                </a:solidFill>
-                <a:latin typeface="Times New Roman"/>
-                <a:ea typeface="Times New Roman"/>
-                <a:cs typeface="Times New Roman"/>
-              </a:defRPr>
-            </a:pPr>
-            <a:r>
-              <a:rPr sz="2250" b="1">
-                <a:solidFill>
-                  <a:srgbClr val="000000"/>
-                </a:solidFill>
-                <a:latin typeface="Times New Roman"/>
-                <a:ea typeface="Times New Roman"/>
-                <a:cs typeface="Times New Roman"/>
-              </a:rPr>
-              <a:t>Deliverables</a:t>
-            </a:r>
-          </a:p>
-        </p:txBody>
-      </p:sp>
-      <p:sp>
-        <p:nvSpPr>
-          <p:cNvPr id="10" name="">
-            <a:extLst xmlns:a="http://schemas.openxmlformats.org/drawingml/2006/main">
-              <a:ext uri="{FF2B5EF4-FFF2-40B4-BE49-F238E27FC236}">
-                <a16:creationId xmlns:a16="http://schemas.microsoft.com/office/drawing/2014/main" id="{24339CFF-6534-4668-8964-38A88D92FFCD}"/>
-              </a:ext>
-            </a:extLst>
-          </p:cNvPr>
-          <p:cNvSpPr>
-            <a:spLocks xmlns:a="http://schemas.openxmlformats.org/drawingml/2006/main" noGrp="1"/>
-          </p:cNvSpPr>
-          <p:nvPr/>
-        </p:nvSpPr>
-        <p:spPr>
-          <a:xfrm xmlns:a="http://schemas.openxmlformats.org/drawingml/2006/main">
-            <a:off x="3429000" y="4048125"/>
-            <a:ext cx="8048625" cy="952500"/>
+            <a:off x="3286125" y="5429250"/>
+            <a:ext cx="8239125" cy="685800"/>
           </a:xfrm>
           <a:prstGeom xmlns:a="http://schemas.openxmlformats.org/drawingml/2006/main" prst="rect">
             <a:avLst/>
@@ -1667,7 +1775,7 @@
                 <a:ea typeface="Times New Roman"/>
                 <a:cs typeface="Times New Roman"/>
               </a:rPr>
-              <a:t>E92 adaptation using 12,269 training images.</a:t>
+              <a:t>One new AI miss prevented full acceptance.</a:t>
             </a:r>
           </a:p>
           <a:p xmlns:a="http://schemas.openxmlformats.org/drawingml/2006/main">
@@ -1690,40 +1798,17 @@
                 <a:ea typeface="Times New Roman"/>
                 <a:cs typeface="Times New Roman"/>
               </a:rPr>
-              <a:t>Local demo and documented experiments.</a:t>
-            </a:r>
-          </a:p>
-          <a:p xmlns:a="http://schemas.openxmlformats.org/drawingml/2006/main">
-            <a:pPr algn="l">
-              <a:defRPr sz="2025" b="0">
-                <a:solidFill>
-                  <a:srgbClr val="000000"/>
-                </a:solidFill>
-                <a:latin typeface="Times New Roman"/>
-                <a:ea typeface="Times New Roman"/>
-                <a:cs typeface="Times New Roman"/>
-              </a:defRPr>
-            </a:pPr>
-            <a:r>
-              <a:rPr sz="2025" b="0">
-                <a:solidFill>
-                  <a:srgbClr val="000000"/>
-                </a:solidFill>
-                <a:latin typeface="Times New Roman"/>
-                <a:ea typeface="Times New Roman"/>
-                <a:cs typeface="Times New Roman"/>
-              </a:rPr>
-              <a:t>Model2 localization remains experimental.</a:t>
+              <a:t>Broader reliability and Model2 remain unproven.</a:t>
             </a:r>
           </a:p>
         </p:txBody>
       </p:sp>
       <p:sp>
         <p:nvSpPr>
-          <p:cNvPr id="11" name="">
+          <p:cNvPr id="12" name="">
             <a:extLst xmlns:a="http://schemas.openxmlformats.org/drawingml/2006/main">
               <a:ext uri="{FF2B5EF4-FFF2-40B4-BE49-F238E27FC236}">
-                <a16:creationId xmlns:a16="http://schemas.microsoft.com/office/drawing/2014/main" id="{DAD1A2FF-5CBB-455F-930E-8C78DD0C481C}"/>
+                <a16:creationId xmlns:a16="http://schemas.microsoft.com/office/drawing/2014/main" id="{5AEFF591-4A2F-4AF0-B947-0430F068C1EC}"/>
               </a:ext>
             </a:extLst>
           </p:cNvPr>
@@ -1734,8 +1819,8 @@
         </p:nvSpPr>
         <p:spPr>
           <a:xfrm xmlns:a="http://schemas.openxmlformats.org/drawingml/2006/main">
-            <a:off x="685800" y="5095875"/>
-            <a:ext cx="2476500" cy="809625"/>
+            <a:off x="685800" y="6381750"/>
+            <a:ext cx="10820400" cy="247650"/>
           </a:xfrm>
           <a:prstGeom xmlns:a="http://schemas.openxmlformats.org/drawingml/2006/main" prst="rect">
             <a:avLst/>
@@ -1752,7 +1837,7 @@
           <a:lstStyle xmlns:a="http://schemas.openxmlformats.org/drawingml/2006/main"/>
           <a:p xmlns:a="http://schemas.openxmlformats.org/drawingml/2006/main">
             <a:pPr algn="l">
-              <a:defRPr sz="2250" b="1">
+              <a:defRPr sz="1425" b="0">
                 <a:solidFill>
                   <a:srgbClr val="000000"/>
                 </a:solidFill>
@@ -1762,7 +1847,7 @@
               </a:defRPr>
             </a:pPr>
             <a:r>
-              <a:rPr sz="2250" b="1">
+              <a:rPr sz="1425" b="0">
                 <a:solidFill>
                   <a:srgbClr val="000000"/>
                 </a:solidFill>
@@ -1770,190 +1855,7 @@
                 <a:ea typeface="Times New Roman"/>
                 <a:cs typeface="Times New Roman"/>
               </a:rPr>
-              <a:t>Development</a:t>
-            </a:r>
-          </a:p>
-          <a:p xmlns:a="http://schemas.openxmlformats.org/drawingml/2006/main">
-            <a:pPr algn="l">
-              <a:defRPr sz="2250" b="1">
-                <a:solidFill>
-                  <a:srgbClr val="000000"/>
-                </a:solidFill>
-                <a:latin typeface="Times New Roman"/>
-                <a:ea typeface="Times New Roman"/>
-                <a:cs typeface="Times New Roman"/>
-              </a:defRPr>
-            </a:pPr>
-            <a:r>
-              <a:rPr sz="2250" b="1">
-                <a:solidFill>
-                  <a:srgbClr val="000000"/>
-                </a:solidFill>
-                <a:latin typeface="Times New Roman"/>
-                <a:ea typeface="Times New Roman"/>
-                <a:cs typeface="Times New Roman"/>
-              </a:rPr>
-              <a:t>result</a:t>
-            </a:r>
-          </a:p>
-        </p:txBody>
-      </p:sp>
-      <p:sp>
-        <p:nvSpPr>
-          <p:cNvPr id="12" name="">
-            <a:extLst xmlns:a="http://schemas.openxmlformats.org/drawingml/2006/main">
-              <a:ext uri="{FF2B5EF4-FFF2-40B4-BE49-F238E27FC236}">
-                <a16:creationId xmlns:a16="http://schemas.microsoft.com/office/drawing/2014/main" id="{E9A2BC92-0EFB-463F-BC42-36CFA28219EF}"/>
-              </a:ext>
-            </a:extLst>
-          </p:cNvPr>
-          <p:cNvSpPr>
-            <a:spLocks xmlns:a="http://schemas.openxmlformats.org/drawingml/2006/main" noGrp="1"/>
-          </p:cNvSpPr>
-          <p:nvPr/>
-        </p:nvSpPr>
-        <p:spPr>
-          <a:xfrm xmlns:a="http://schemas.openxmlformats.org/drawingml/2006/main">
-            <a:off x="3429000" y="5095875"/>
-            <a:ext cx="8048625" cy="828675"/>
-          </a:xfrm>
-          <a:prstGeom xmlns:a="http://schemas.openxmlformats.org/drawingml/2006/main" prst="rect">
-            <a:avLst/>
-          </a:prstGeom>
-          <a:noFill xmlns:a="http://schemas.openxmlformats.org/drawingml/2006/main"/>
-          <a:ln xmlns:a="http://schemas.openxmlformats.org/drawingml/2006/main" w="0">
-            <a:noFill/>
-          </a:ln>
-        </p:spPr>
-        <p:txBody>
-          <a:bodyPr xmlns:a="http://schemas.openxmlformats.org/drawingml/2006/main">
-            <a:noAutofit/>
-          </a:bodyPr>
-          <a:lstStyle xmlns:a="http://schemas.openxmlformats.org/drawingml/2006/main"/>
-          <a:p xmlns:a="http://schemas.openxmlformats.org/drawingml/2006/main">
-            <a:pPr algn="l">
-              <a:defRPr sz="1875" b="0">
-                <a:solidFill>
-                  <a:srgbClr val="000000"/>
-                </a:solidFill>
-                <a:latin typeface="Times New Roman"/>
-                <a:ea typeface="Times New Roman"/>
-                <a:cs typeface="Times New Roman"/>
-              </a:defRPr>
-            </a:pPr>
-            <a:r>
-              <a:rPr sz="1875" b="0">
-                <a:solidFill>
-                  <a:srgbClr val="000000"/>
-                </a:solidFill>
-                <a:latin typeface="Times New Roman"/>
-                <a:ea typeface="Times New Roman"/>
-                <a:cs typeface="Times New Roman"/>
-              </a:rPr>
-              <a:t>Reused data: 159/160 AI detected in each condition.</a:t>
-            </a:r>
-          </a:p>
-          <a:p xmlns:a="http://schemas.openxmlformats.org/drawingml/2006/main">
-            <a:pPr algn="l">
-              <a:defRPr sz="1875" b="0">
-                <a:solidFill>
-                  <a:srgbClr val="000000"/>
-                </a:solidFill>
-                <a:latin typeface="Times New Roman"/>
-                <a:ea typeface="Times New Roman"/>
-                <a:cs typeface="Times New Roman"/>
-              </a:defRPr>
-            </a:pPr>
-            <a:r>
-              <a:rPr sz="1875" b="0">
-                <a:solidFill>
-                  <a:srgbClr val="000000"/>
-                </a:solidFill>
-                <a:latin typeface="Times New Roman"/>
-                <a:ea typeface="Times New Roman"/>
-                <a:cs typeface="Times New Roman"/>
-              </a:rPr>
-              <a:t>Real false alerts: 0/160 original; 14/160 processed.</a:t>
-            </a:r>
-          </a:p>
-          <a:p xmlns:a="http://schemas.openxmlformats.org/drawingml/2006/main">
-            <a:pPr algn="l">
-              <a:defRPr sz="1875" b="0">
-                <a:solidFill>
-                  <a:srgbClr val="000000"/>
-                </a:solidFill>
-                <a:latin typeface="Times New Roman"/>
-                <a:ea typeface="Times New Roman"/>
-                <a:cs typeface="Times New Roman"/>
-              </a:defRPr>
-            </a:pPr>
-            <a:r>
-              <a:rPr sz="1875" b="0">
-                <a:solidFill>
-                  <a:srgbClr val="000000"/>
-                </a:solidFill>
-                <a:latin typeface="Times New Roman"/>
-                <a:ea typeface="Times New Roman"/>
-                <a:cs typeface="Times New Roman"/>
-              </a:rPr>
-              <a:t>20/20 numerical checks; one new AI miss blocked acceptance.</a:t>
-            </a:r>
-          </a:p>
-        </p:txBody>
-      </p:sp>
-      <p:sp>
-        <p:nvSpPr>
-          <p:cNvPr id="13" name="">
-            <a:extLst xmlns:a="http://schemas.openxmlformats.org/drawingml/2006/main">
-              <a:ext uri="{FF2B5EF4-FFF2-40B4-BE49-F238E27FC236}">
-                <a16:creationId xmlns:a16="http://schemas.microsoft.com/office/drawing/2014/main" id="{C0E35F99-5531-418B-9576-93B874BE3524}"/>
-              </a:ext>
-            </a:extLst>
-          </p:cNvPr>
-          <p:cNvSpPr>
-            <a:spLocks xmlns:a="http://schemas.openxmlformats.org/drawingml/2006/main" noGrp="1"/>
-          </p:cNvSpPr>
-          <p:nvPr/>
-        </p:nvSpPr>
-        <p:spPr>
-          <a:xfrm xmlns:a="http://schemas.openxmlformats.org/drawingml/2006/main">
-            <a:off x="685800" y="5981700"/>
-            <a:ext cx="10820400" cy="266700"/>
-          </a:xfrm>
-          <a:prstGeom xmlns:a="http://schemas.openxmlformats.org/drawingml/2006/main" prst="rect">
-            <a:avLst/>
-          </a:prstGeom>
-          <a:noFill xmlns:a="http://schemas.openxmlformats.org/drawingml/2006/main"/>
-          <a:ln xmlns:a="http://schemas.openxmlformats.org/drawingml/2006/main" w="0">
-            <a:noFill/>
-          </a:ln>
-        </p:spPr>
-        <p:txBody>
-          <a:bodyPr xmlns:a="http://schemas.openxmlformats.org/drawingml/2006/main">
-            <a:noAutofit/>
-          </a:bodyPr>
-          <a:lstStyle xmlns:a="http://schemas.openxmlformats.org/drawingml/2006/main"/>
-          <a:p xmlns:a="http://schemas.openxmlformats.org/drawingml/2006/main">
-            <a:pPr algn="l">
-              <a:defRPr sz="1500" b="0">
-                <a:solidFill>
-                  <a:srgbClr val="000000"/>
-                </a:solidFill>
-                <a:latin typeface="Times New Roman"/>
-                <a:ea typeface="Times New Roman"/>
-                <a:cs typeface="Times New Roman"/>
-              </a:defRPr>
-            </a:pPr>
-            <a:r>
-              <a:rPr sz="1500" b="0">
-                <a:solidFill>
-                  <a:srgbClr val="000000"/>
-                </a:solidFill>
-                <a:latin typeface="Times New Roman"/>
-                <a:ea typeface="Times New Roman"/>
-                <a:cs typeface="Times New Roman"/>
-              </a:rPr>
-              <a:t>Supervisor: Önder Çelebi, Director · Submission date: [TO COMPLETE]</a:t>
+              <a:t>Supervisor: Önder Çelebi, Director   Submission date: [TO COMPLETE]</a:t>
             </a:r>
           </a:p>
         </p:txBody>
@@ -1961,7 +1863,7 @@
     </p:spTree>
     <p:extLst>
       <p:ext uri="{BB962C8B-B14F-4D97-AF65-F5344CB8AC3E}">
-        <p14:creationId xmlns:p14="http://schemas.microsoft.com/office/powerpoint/2010/main" val="1288607088"/>
+        <p14:creationId xmlns:p14="http://schemas.microsoft.com/office/powerpoint/2010/main" val="1880478698"/>
       </p:ext>
     </p:extLst>
   </p:cSld>

</xml_diff>